<commit_message>
Reorganiza la presentación en las 6 secciones nuevas y presenta la arquitectura en N capas
Co-Authored-By: Claude Sonnet 5.5 <noreply@anthropic.com>
</commit_message>
<xml_diff>
--- a/Presentacion/Presentacion_Final_GestionContratos.pptx
+++ b/Presentacion/Presentacion_Final_GestionContratos.pptx
@@ -12,11 +12,14 @@
     <p:sldId id="257" r:id="rId3"/>
     <p:sldId id="258" r:id="rId4"/>
     <p:sldId id="259" r:id="rId5"/>
+    <p:sldId id="268" r:id="rId19"/>
+    <p:sldId id="264" r:id="rId10"/>
     <p:sldId id="260" r:id="rId6"/>
     <p:sldId id="261" r:id="rId7"/>
     <p:sldId id="262" r:id="rId8"/>
+    <p:sldId id="269" r:id="rId20"/>
     <p:sldId id="263" r:id="rId9"/>
-    <p:sldId id="264" r:id="rId10"/>
+    <p:sldId id="270" r:id="rId21"/>
     <p:sldId id="265" r:id="rId11"/>
     <p:sldId id="266" r:id="rId12"/>
     <p:sldId id="267" r:id="rId13"/>
@@ -329,8 +332,7 @@
           <a:lstStyle/>
           <a:p>
             <a:r>
-              <a:rPr lang="en-US" dirty="0"/>
-              <a:t>Buenos días. Soy Yuri Grandez y voy a presentar GestionContratos, el sistema que desarrollé para la empresa familiar DA Soluciones e Inversiones como proyecto integrador del curso de Galaxy Training. El profesor es Manuel Moyano. En los próximos minutos contaré qué problema resuelve, cómo lo especifiqué y construí, cómo usé la inteligencia artificial y cómo se ve funcionando.</a:t>
+              <a:t>Buenos días. Soy Yuri Grandez y voy a presentar GestionContratos, el sistema que desarrollé para la empresa familiar DA Soluciones e Inversiones como proyecto integrador del curso de Galaxy Training. El profesor es Manuel Moyano. La presentación sigue seis partes: el problema y su valor, las especificaciones y su trazabilidad, la arquitectura y las decisiones técnicas, el uso de inteligencia artificial con su evidencia de revisión, la demostración del sistema, y las conclusiones con las mejoras pendientes.</a:t>
             </a:r>
           </a:p>
         </p:txBody>
@@ -632,6 +634,144 @@
 </p:notes>
 </file>
 
+<file path=ppt/notesSlides/notesSlide13.xml><?xml version="1.0" encoding="utf-8"?>
+<p:notes xmlns:a="http://schemas.openxmlformats.org/drawingml/2006/main" xmlns:p="http://schemas.openxmlformats.org/presentationml/2006/main" xmlns:r="http://schemas.openxmlformats.org/officeDocument/2006/relationships">
+  <p:cSld>
+    <p:spTree>
+      <p:nvGrpSpPr>
+        <p:cNvPr id="1" name=""/>
+        <p:cNvGrpSpPr/>
+        <p:nvPr/>
+      </p:nvGrpSpPr>
+      <p:grpSpPr>
+        <a:xfrm>
+          <a:off x="0" y="0"/>
+          <a:ext cx="0" cy="0"/>
+          <a:chOff x="0" y="0"/>
+          <a:chExt cx="0" cy="0"/>
+        </a:xfrm>
+      </p:grpSpPr>
+      <p:sp>
+        <p:nvSpPr>
+          <p:cNvPr id="3" name="Notes Placeholder 2"/>
+          <p:cNvSpPr>
+            <a:spLocks noGrp="1"/>
+          </p:cNvSpPr>
+          <p:nvPr>
+            <p:ph type="body" idx="1"/>
+          </p:nvPr>
+        </p:nvSpPr>
+        <p:spPr/>
+        <p:txBody>
+          <a:bodyPr/>
+          <a:lstStyle/>
+          <a:p>
+            <a:r>
+              <a:t>Esta es la trazabilidad de un requisito real. El requisito RF-09 es autorizar un contrato. La regla RN-07 dice que lo autoriza un administrador distinto del que lo registró. Está implementada en el método Autorizar de ContratosServicio, expuesto en POST api/contratos/{id}/autorizar, y la comprueba la prueba de xUnit Autorizar_RegistradoPorElMismoUsuario_Devuelve400. La matriz completa está en el documento de especificación y trazabilidad (SDD). Nota para el orador: el proyecto se especificó con requisitos funcionales, reglas de negocio y requisitos no funcionales; no se redactaron historias de usuario ni casos de uso formales, y cada RF cumple ese papel con su criterio de aceptación.</a:t>
+            </a:r>
+          </a:p>
+        </p:txBody>
+      </p:sp>
+    </p:spTree>
+  </p:cSld>
+  <p:clrMapOvr>
+    <a:masterClrMapping/>
+  </p:clrMapOvr>
+</p:notes>
+</file>
+
+<file path=ppt/notesSlides/notesSlide14.xml><?xml version="1.0" encoding="utf-8"?>
+<p:notes xmlns:a="http://schemas.openxmlformats.org/drawingml/2006/main" xmlns:p="http://schemas.openxmlformats.org/presentationml/2006/main" xmlns:r="http://schemas.openxmlformats.org/officeDocument/2006/relationships">
+  <p:cSld>
+    <p:spTree>
+      <p:nvGrpSpPr>
+        <p:cNvPr id="1" name=""/>
+        <p:cNvGrpSpPr/>
+        <p:nvPr/>
+      </p:nvGrpSpPr>
+      <p:grpSpPr>
+        <a:xfrm>
+          <a:off x="0" y="0"/>
+          <a:ext cx="0" cy="0"/>
+          <a:chOff x="0" y="0"/>
+          <a:chExt cx="0" cy="0"/>
+        </a:xfrm>
+      </p:grpSpPr>
+      <p:sp>
+        <p:nvSpPr>
+          <p:cNvPr id="3" name="Notes Placeholder 2"/>
+          <p:cNvSpPr>
+            <a:spLocks noGrp="1"/>
+          </p:cNvSpPr>
+          <p:nvPr>
+            <p:ph type="body" idx="1"/>
+          </p:nvPr>
+        </p:nvSpPr>
+        <p:spPr/>
+        <p:txBody>
+          <a:bodyPr/>
+          <a:lstStyle/>
+          <a:p>
+            <a:r>
+              <a:t>Estas son evidencias concretas, no afirmaciones. Primera: en la fase dos pedí usar user-secrets y variables de entorno y que esos valores nunca se suban a GitHub; esa restricción la puse antes de que se escribiera código, y el resultado está en el commit 0c6a73c. Segunda: ante la duda entre Vitest y Karma pedí una comparación de esfuerzo y tokens y decidí yo. Tercera: el diff del commit 747cce4 muestra cómo la IA corrigió el script de base de datos, más 238 y menos 47 líneas; no lo acepté sin comprobar: ejecuté Instalar.sql en SQL Server. Los tres documentos de prompts están en la carpeta Prompts del repositorio y la coautoría de la IA figura en cada commit. Esto es lo contrario del vibe coding: cada propuesta pasó por una revisión.</a:t>
+            </a:r>
+          </a:p>
+        </p:txBody>
+      </p:sp>
+    </p:spTree>
+  </p:cSld>
+  <p:clrMapOvr>
+    <a:masterClrMapping/>
+  </p:clrMapOvr>
+</p:notes>
+</file>
+
+<file path=ppt/notesSlides/notesSlide15.xml><?xml version="1.0" encoding="utf-8"?>
+<p:notes xmlns:a="http://schemas.openxmlformats.org/drawingml/2006/main" xmlns:p="http://schemas.openxmlformats.org/presentationml/2006/main" xmlns:r="http://schemas.openxmlformats.org/officeDocument/2006/relationships">
+  <p:cSld>
+    <p:spTree>
+      <p:nvGrpSpPr>
+        <p:cNvPr id="1" name=""/>
+        <p:cNvGrpSpPr/>
+        <p:nvPr/>
+      </p:nvGrpSpPr>
+      <p:grpSpPr>
+        <a:xfrm>
+          <a:off x="0" y="0"/>
+          <a:ext cx="0" cy="0"/>
+          <a:chOff x="0" y="0"/>
+          <a:chExt cx="0" cy="0"/>
+        </a:xfrm>
+      </p:grpSpPr>
+      <p:sp>
+        <p:nvSpPr>
+          <p:cNvPr id="3" name="Notes Placeholder 2"/>
+          <p:cNvSpPr>
+            <a:spLocks noGrp="1"/>
+          </p:cNvSpPr>
+          <p:nvPr>
+            <p:ph type="body" idx="1"/>
+          </p:nvPr>
+        </p:nvSpPr>
+        <p:spPr/>
+        <p:txBody>
+          <a:bodyPr/>
+          <a:lstStyle/>
+          <a:p>
+            <a:r>
+              <a:t>Antes de ir a la web muestro la API documentada con OpenAPI. Los endpoints principales son el login, el CRUD de clientes, empresas y locales, la autorización de contratos, el registro y la anulación de pagos y las analíticas del panel. Mostraré las respuestas de las reglas: sin token responde 401, un operador en una ruta de administrador recibe 403, autorizar un contrato con el mismo usuario que lo registró devuelve 400, un pago mayor al saldo devuelve 400, y los errores de negocio nunca terminan en un 500. Luego paso a la web.</a:t>
+            </a:r>
+          </a:p>
+        </p:txBody>
+      </p:sp>
+    </p:spTree>
+  </p:cSld>
+  <p:clrMapOvr>
+    <a:masterClrMapping/>
+  </p:clrMapOvr>
+</p:notes>
+</file>
+
 <file path=ppt/notesSlides/notesSlide2.xml><?xml version="1.0" encoding="utf-8"?>
 <p:notes xmlns:a="http://schemas.openxmlformats.org/drawingml/2006/main" xmlns:r="http://schemas.openxmlformats.org/officeDocument/2006/relationships" xmlns:p="http://schemas.openxmlformats.org/presentationml/2006/main">
   <p:cSld>
@@ -677,8 +817,7 @@
           <a:lstStyle/>
           <a:p>
             <a:r>
-              <a:rPr lang="en-US" dirty="0"/>
-              <a:t>El dueño de los locales tiene tres preguntas de todos los días: qué locales están ocupados, cuánto le deben y qué contratos vencen pronto. Responderlas sin un sistema obliga a revisar papeles y hojas sueltas. La propuesta de valor es contestar las tres en una sola pantalla.</a:t>
+              <a:t>El dueño de los locales tiene tres preguntas de todos los días: qué locales están ocupados, cuánto le deben y qué contratos vencen pronto. Responderlas sin un sistema obliga a revisar papeles y hojas sueltas. La propuesta de valor es contestar las tres en una sola pantalla. Esta es la historia que seguiremos: el problema, cómo lo especificamos, cómo lo construimos y cómo lo comprobamos.</a:t>
             </a:r>
           </a:p>
         </p:txBody>
@@ -938,8 +1077,7 @@
           <a:lstStyle/>
           <a:p>
             <a:r>
-              <a:rPr lang="en-US" dirty="0"/>
-              <a:t>Usamos una arquitectura en capas, como los pisos de un edificio. Arriba están las pantallas; luego la puerta de entrada, que recibe los pedidos; después las reglas del negocio; el acceso a los datos; y abajo la base de datos. La elegimos porque cada parte tiene una sola tarea y porque el curso pide separar responsabilidades. Los beneficios: se puede probar cada capa por separado, un cambio en una parte no rompe las demás, y el sistema está listo para crecer; por ejemplo, la facturación electrónica ya tiene un proyecto reservado donde conectarse sin tocar el resto.</a:t>
+              <a:t>El backend está organizado en N capas, con una solución y un proyecto por capa, como se definió en el documento de arquitectura. Arriba la API, que recibe los pedidos y no tiene lógica de negocio. Luego Negocio, con los servicios, las reglas y las analíticas. Después Datos, con Entity Framework Core sobre SQL Server, los repositorios y el Unit of Work. Y al fondo Entidades, que mapean las tablas y no dependen de ninguna otra capa. Los proyectos de apoyo son DTOs, Comun, Integraciones, reservada para la facturación electrónica, y Pruebas. Las dependencias van en un solo sentido y la API nunca habla directo con Datos. El frontend en Angular 21 consume la API documentada con OpenAPI.</a:t>
             </a:r>
           </a:p>
         </p:txBody>
@@ -1025,8 +1163,7 @@
           <a:lstStyle/>
           <a:p>
             <a:r>
-              <a:rPr lang="en-US" dirty="0"/>
-              <a:t>Además de las capas, tomamos cuatro decisiones importantes. Primero, la base de datos: es la fuente de verdad y el código se generó a partir de ella. Segundo, las claves y contraseñas nunca se suben al repositorio. Tercero, nada se borra de verdad: los registros se desactivan para conservar el historial. Y cuarto, la web y el sistema se instalan juntos como un solo sitio en IIS.</a:t>
+              <a:t>Estas son las decisiones técnicas clave, escritas como registros de decisión (ADR) en docs/Arquitectura.md. Primero, la base de datos: es la fuente de verdad y las entidades se generan con el scaffold de Entity Framework Core. Segundo, la cadena de conexión y la clave JWT viven en user-secrets y variables de entorno, nunca en GitHub. Tercero, baja lógica: nada se borra de verdad, se desactiva con un filtro global de EF Core. Y cuarto, la API sirve la web compilada para instalar un solo sitio en IIS.</a:t>
             </a:r>
           </a:p>
         </p:txBody>
@@ -1112,8 +1249,7 @@
           <a:lstStyle/>
           <a:p>
             <a:r>
-              <a:rPr lang="en-US" dirty="0"/>
-              <a:t>Usé Claude Code como asistente. Yo definí el problema, las reglas y las restricciones; la IA propuso la arquitectura y escribió el código, las pruebas y la documentación; y todo se verificó con pruebas automáticas y manuales. La participación de la IA es visible: los 15 commits la indican como coautora y los prompts están guardados en el repositorio.</a:t>
+              <a:t>Usé Claude Code como asistente. Yo definí el problema, las reglas y las restricciones; la IA implementó la arquitectura en N capas que yo indiqué y escribió el código, las pruebas y la documentación; y todo se verificó con pruebas automáticas y manuales. La participación de la IA es visible: los 15 commits la indican como coautora y los prompts están guardados en el repositorio.</a:t>
             </a:r>
           </a:p>
         </p:txBody>
@@ -3579,9 +3715,44 @@
             <a:pPr algn="r"/>
             <a:fld id="{F7021451-1387-4CA6-816F-3879F97B5CBC}" type="slidenum">
               <a:rPr lang="en-US" b="0"/>
-              <a:t>10</a:t>
+              <a:t>13</a:t>
             </a:fld>
             <a:endParaRPr lang="en-US"/>
+          </a:p>
+        </p:txBody>
+      </p:sp>
+      <p:sp>
+        <p:nvSpPr>
+          <p:cNvPr id="29" name="Etiqueta de sección"/>
+          <p:cNvSpPr txBox="1"/>
+          <p:nvPr/>
+        </p:nvSpPr>
+        <p:spPr>
+          <a:xfrm>
+            <a:off x="457200" y="91440"/>
+            <a:ext cx="7863840" cy="228600"/>
+          </a:xfrm>
+          <a:prstGeom prst="rect">
+            <a:avLst/>
+          </a:prstGeom>
+          <a:noFill/>
+        </p:spPr>
+        <p:txBody>
+          <a:bodyPr wrap="square" lIns="0" rIns="0" tIns="0" bIns="0" anchor="ctr">
+            <a:spAutoFit/>
+          </a:bodyPr>
+          <a:lstStyle/>
+          <a:p>
+            <a:pPr algn="l"/>
+            <a:r>
+              <a:rPr sz="1100" b="1">
+                <a:solidFill>
+                  <a:schemeClr val="accent1"/>
+                </a:solidFill>
+                <a:latin typeface="Calibri"/>
+              </a:rPr>
+              <a:t>5 · DEMOSTRACIÓN FUNCIONAL</a:t>
+            </a:r>
           </a:p>
         </p:txBody>
       </p:sp>
@@ -4173,9 +4344,44 @@
             <a:pPr algn="r"/>
             <a:fld id="{F7021451-1387-4CA6-816F-3879F97B5CBC}" type="slidenum">
               <a:rPr lang="en-US" b="0"/>
-              <a:t>11</a:t>
+              <a:t>14</a:t>
             </a:fld>
             <a:endParaRPr lang="en-US"/>
+          </a:p>
+        </p:txBody>
+      </p:sp>
+      <p:sp>
+        <p:nvSpPr>
+          <p:cNvPr id="26" name="Etiqueta de sección"/>
+          <p:cNvSpPr txBox="1"/>
+          <p:nvPr/>
+        </p:nvSpPr>
+        <p:spPr>
+          <a:xfrm>
+            <a:off x="457200" y="91440"/>
+            <a:ext cx="7863840" cy="228600"/>
+          </a:xfrm>
+          <a:prstGeom prst="rect">
+            <a:avLst/>
+          </a:prstGeom>
+          <a:noFill/>
+        </p:spPr>
+        <p:txBody>
+          <a:bodyPr wrap="square" lIns="0" rIns="0" tIns="0" bIns="0" anchor="ctr">
+            <a:spAutoFit/>
+          </a:bodyPr>
+          <a:lstStyle/>
+          <a:p>
+            <a:pPr algn="l"/>
+            <a:r>
+              <a:rPr sz="1100" b="1">
+                <a:solidFill>
+                  <a:schemeClr val="accent1"/>
+                </a:solidFill>
+                <a:latin typeface="Calibri"/>
+              </a:rPr>
+              <a:t>6 · CONCLUSIONES, APRENDIZAJES Y MEJORAS</a:t>
+            </a:r>
           </a:p>
         </p:txBody>
       </p:sp>
@@ -4732,9 +4938,2129 @@
             <a:pPr algn="r"/>
             <a:fld id="{F7021451-1387-4CA6-816F-3879F97B5CBC}" type="slidenum">
               <a:rPr lang="en-US" b="0"/>
+              <a:t>15</a:t>
+            </a:fld>
+            <a:endParaRPr lang="en-US"/>
+          </a:p>
+        </p:txBody>
+      </p:sp>
+      <p:sp>
+        <p:nvSpPr>
+          <p:cNvPr id="26" name="Etiqueta de sección"/>
+          <p:cNvSpPr txBox="1"/>
+          <p:nvPr/>
+        </p:nvSpPr>
+        <p:spPr>
+          <a:xfrm>
+            <a:off x="457200" y="91440"/>
+            <a:ext cx="7863840" cy="228600"/>
+          </a:xfrm>
+          <a:prstGeom prst="rect">
+            <a:avLst/>
+          </a:prstGeom>
+          <a:noFill/>
+        </p:spPr>
+        <p:txBody>
+          <a:bodyPr wrap="square" lIns="0" rIns="0" tIns="0" bIns="0" anchor="ctr">
+            <a:spAutoFit/>
+          </a:bodyPr>
+          <a:lstStyle/>
+          <a:p>
+            <a:pPr algn="l"/>
+            <a:r>
+              <a:rPr sz="1100" b="1">
+                <a:solidFill>
+                  <a:schemeClr val="accent5"/>
+                </a:solidFill>
+                <a:latin typeface="Calibri"/>
+              </a:rPr>
+              <a:t>6 · CONCLUSIONES, APRENDIZAJES Y MEJORAS</a:t>
+            </a:r>
+          </a:p>
+        </p:txBody>
+      </p:sp>
+    </p:spTree>
+  </p:cSld>
+  <p:clrMapOvr>
+    <a:masterClrMapping/>
+  </p:clrMapOvr>
+</p:sld>
+</file>
+
+<file path=ppt/slides/slide13.xml><?xml version="1.0" encoding="utf-8"?>
+<p:sld xmlns:a="http://schemas.openxmlformats.org/drawingml/2006/main" xmlns:p="http://schemas.openxmlformats.org/presentationml/2006/main" xmlns:r="http://schemas.openxmlformats.org/officeDocument/2006/relationships">
+  <p:cSld>
+    <p:spTree>
+      <p:nvGrpSpPr>
+        <p:cNvPr id="1" name=""/>
+        <p:cNvGrpSpPr/>
+        <p:nvPr/>
+      </p:nvGrpSpPr>
+      <p:grpSpPr/>
+      <p:sp>
+        <p:nvSpPr>
+          <p:cNvPr id="2" name="Text 1"/>
+          <p:cNvSpPr>
+            <a:spLocks noGrp="1"/>
+          </p:cNvSpPr>
+          <p:nvPr>
+            <p:ph type="title" idx="102" hasCustomPrompt="1"/>
+          </p:nvPr>
+        </p:nvSpPr>
+        <p:spPr>
+          <a:xfrm>
+            <a:off x="457200" y="274320"/>
+            <a:ext cx="7589520" cy="731520"/>
+          </a:xfrm>
+          <a:prstGeom prst="rect">
+            <a:avLst/>
+          </a:prstGeom>
+          <a:noFill/>
+          <a:ln/>
+        </p:spPr>
+        <p:txBody>
+          <a:bodyPr wrap="square" lIns="0" tIns="0" rIns="0" bIns="0" rtlCol="0" anchor="ctr"/>
+          <a:lstStyle/>
+          <a:p>
+            <a:pPr marL="0" indent="0" algn="l">
+              <a:buNone/>
+            </a:pPr>
+            <a:r>
+              <a:rPr lang="en-US" sz="3000" b="1" dirty="0">
+                <a:solidFill>
+                  <a:schemeClr val="tx2"/>
+                </a:solidFill>
+                <a:latin typeface="Cambria" pitchFamily="34" charset="0"/>
+                <a:ea typeface="Cambria" pitchFamily="34" charset="-122"/>
+                <a:cs typeface="Cambria" pitchFamily="34" charset="-120"/>
+              </a:rPr>
+              <a:t>Del requisito a la prueba</a:t>
+            </a:r>
+            <a:endParaRPr lang="en-US" sz="3000" dirty="0"/>
+          </a:p>
+        </p:txBody>
+      </p:sp>
+      <p:sp>
+        <p:nvSpPr>
+          <p:cNvPr id="25" name="Slide Number Placeholder 0"/>
+          <p:cNvSpPr>
+            <a:spLocks noGrp="1"/>
+          </p:cNvSpPr>
+          <p:nvPr>
+            <p:ph type="sldNum" sz="quarter" idx="4294967295"/>
+          </p:nvPr>
+        </p:nvSpPr>
+        <p:spPr>
+          <a:xfrm>
+            <a:off x="8229600" y="4754880"/>
+            <a:ext cx="457200" cy="228600"/>
+          </a:xfrm>
+          <a:prstGeom prst="rect">
+            <a:avLst/>
+          </a:prstGeom>
+          <a:extLst>
+            <a:ext uri="{C572A759-6A51-4108-AA02-DFA0A04FC94B}">
+              <ma14:wrappingTextBoxFlag xmlns:ma14="http://schemas.microsoft.com/office/mac/drawingml/2011/main" xmlns="" val="0"/>
+            </a:ext>
+          </a:extLst>
+        </p:spPr>
+        <p:txBody>
+          <a:bodyPr/>
+          <a:lstStyle>
+            <a:lvl1pPr>
+              <a:defRPr sz="1000">
+                <a:solidFill>
+                  <a:schemeClr val="tx2"/>
+                </a:solidFill>
+              </a:defRPr>
+            </a:lvl1pPr>
+          </a:lstStyle>
+          <a:p>
+            <a:pPr algn="r"/>
+            <a:fld id="{F7021451-1387-4CA6-816F-3879F97B5CBC}" type="slidenum">
+              <a:rPr lang="en-US" b="0"/>
+              <a:t>5</a:t>
+            </a:fld>
+            <a:endParaRPr lang="en-US"/>
+          </a:p>
+        </p:txBody>
+      </p:sp>
+      <p:sp>
+        <p:nvSpPr>
+          <p:cNvPr id="26" name="Etiqueta de sección"/>
+          <p:cNvSpPr txBox="1"/>
+          <p:nvPr/>
+        </p:nvSpPr>
+        <p:spPr>
+          <a:xfrm>
+            <a:off x="457200" y="91440"/>
+            <a:ext cx="7863840" cy="228600"/>
+          </a:xfrm>
+          <a:prstGeom prst="rect">
+            <a:avLst/>
+          </a:prstGeom>
+          <a:noFill/>
+        </p:spPr>
+        <p:txBody>
+          <a:bodyPr wrap="square" lIns="0" rIns="0" tIns="0" bIns="0" anchor="ctr">
+            <a:spAutoFit/>
+          </a:bodyPr>
+          <a:lstStyle/>
+          <a:p>
+            <a:pPr algn="l"/>
+            <a:r>
+              <a:rPr sz="1100" b="1">
+                <a:solidFill>
+                  <a:schemeClr val="accent1"/>
+                </a:solidFill>
+                <a:latin typeface="Calibri"/>
+              </a:rPr>
+              <a:t>2 · ESPECIFICACIONES Y TRAZABILIDAD</a:t>
+            </a:r>
+          </a:p>
+        </p:txBody>
+      </p:sp>
+      <p:sp>
+        <p:nvSpPr>
+          <p:cNvPr id="27" name="Paso 1"/>
+          <p:cNvSpPr/>
+          <p:nvPr/>
+        </p:nvSpPr>
+        <p:spPr>
+          <a:xfrm>
+            <a:off x="457200" y="1188720"/>
+            <a:ext cx="1828800" cy="2148840"/>
+          </a:xfrm>
+          <a:prstGeom prst="roundRect">
+            <a:avLst>
+              <a:gd name="adj" fmla="val 5000"/>
+            </a:avLst>
+          </a:prstGeom>
+          <a:solidFill>
+            <a:schemeClr val="bg2"/>
+          </a:solidFill>
+          <a:ln w="12700">
+            <a:solidFill>
+              <a:srgbClr val="DCE4EA"/>
+            </a:solidFill>
+          </a:ln>
+        </p:spPr>
+        <p:txBody>
+          <a:bodyPr rtlCol="0" anchor="ctr"/>
+          <a:lstStyle/>
+          <a:p>
+            <a:pPr algn="ctr"/>
+          </a:p>
+        </p:txBody>
+      </p:sp>
+      <p:sp>
+        <p:nvSpPr>
+          <p:cNvPr id="28" name="Cabecera paso 1"/>
+          <p:cNvSpPr txBox="1"/>
+          <p:nvPr/>
+        </p:nvSpPr>
+        <p:spPr>
+          <a:xfrm>
+            <a:off x="594360" y="1325880"/>
+            <a:ext cx="1554480" cy="274320"/>
+          </a:xfrm>
+          <a:prstGeom prst="rect">
+            <a:avLst/>
+          </a:prstGeom>
+          <a:noFill/>
+        </p:spPr>
+        <p:txBody>
+          <a:bodyPr wrap="square" lIns="0" rIns="0" tIns="0" bIns="0" anchor="t">
+            <a:spAutoFit/>
+          </a:bodyPr>
+          <a:lstStyle/>
+          <a:p>
+            <a:pPr algn="l"/>
+            <a:r>
+              <a:rPr sz="1400" b="1">
+                <a:solidFill>
+                  <a:schemeClr val="accent1"/>
+                </a:solidFill>
+                <a:latin typeface="Calibri"/>
+              </a:rPr>
+              <a:t>Requisito</a:t>
+            </a:r>
+          </a:p>
+        </p:txBody>
+      </p:sp>
+      <p:sp>
+        <p:nvSpPr>
+          <p:cNvPr id="29" name="Código paso 1"/>
+          <p:cNvSpPr txBox="1"/>
+          <p:nvPr/>
+        </p:nvSpPr>
+        <p:spPr>
+          <a:xfrm>
+            <a:off x="594360" y="1645920"/>
+            <a:ext cx="1554480" cy="457200"/>
+          </a:xfrm>
+          <a:prstGeom prst="rect">
+            <a:avLst/>
+          </a:prstGeom>
+          <a:noFill/>
+        </p:spPr>
+        <p:txBody>
+          <a:bodyPr wrap="square" lIns="0" rIns="0" tIns="0" bIns="0" anchor="t">
+            <a:spAutoFit/>
+          </a:bodyPr>
+          <a:lstStyle/>
+          <a:p>
+            <a:pPr algn="l"/>
+            <a:r>
+              <a:rPr sz="2400" b="1">
+                <a:solidFill>
+                  <a:schemeClr val="tx2"/>
+                </a:solidFill>
+                <a:latin typeface="Cambria"/>
+              </a:rPr>
+              <a:t>RF-09</a:t>
+            </a:r>
+          </a:p>
+        </p:txBody>
+      </p:sp>
+      <p:sp>
+        <p:nvSpPr>
+          <p:cNvPr id="30" name="Detalle paso 1"/>
+          <p:cNvSpPr txBox="1"/>
+          <p:nvPr/>
+        </p:nvSpPr>
+        <p:spPr>
+          <a:xfrm>
+            <a:off x="594360" y="2194560"/>
+            <a:ext cx="1554480" cy="1051560"/>
+          </a:xfrm>
+          <a:prstGeom prst="rect">
+            <a:avLst/>
+          </a:prstGeom>
+          <a:noFill/>
+        </p:spPr>
+        <p:txBody>
+          <a:bodyPr wrap="square" lIns="0" rIns="0" tIns="0" bIns="0" anchor="t">
+            <a:spAutoFit/>
+          </a:bodyPr>
+          <a:lstStyle/>
+          <a:p>
+            <a:pPr algn="l"/>
+            <a:r>
+              <a:rPr sz="1400" b="0">
+                <a:solidFill>
+                  <a:schemeClr val="tx2"/>
+                </a:solidFill>
+                <a:latin typeface="Calibri"/>
+              </a:rPr>
+              <a:t>Autorizar un contrato</a:t>
+            </a:r>
+          </a:p>
+        </p:txBody>
+      </p:sp>
+      <p:sp>
+        <p:nvSpPr>
+          <p:cNvPr id="31" name="Flecha 1"/>
+          <p:cNvSpPr txBox="1"/>
+          <p:nvPr/>
+        </p:nvSpPr>
+        <p:spPr>
+          <a:xfrm>
+            <a:off x="2286000" y="2080260"/>
+            <a:ext cx="304495" cy="365760"/>
+          </a:xfrm>
+          <a:prstGeom prst="rect">
+            <a:avLst/>
+          </a:prstGeom>
+          <a:noFill/>
+        </p:spPr>
+        <p:txBody>
+          <a:bodyPr wrap="square" lIns="0" rIns="0" tIns="0" bIns="0" anchor="ctr">
+            <a:spAutoFit/>
+          </a:bodyPr>
+          <a:lstStyle/>
+          <a:p>
+            <a:pPr algn="ctr"/>
+            <a:r>
+              <a:rPr sz="2200" b="1">
+                <a:solidFill>
+                  <a:schemeClr val="accent3"/>
+                </a:solidFill>
+                <a:latin typeface="Calibri"/>
+              </a:rPr>
+              <a:t>→</a:t>
+            </a:r>
+          </a:p>
+        </p:txBody>
+      </p:sp>
+      <p:sp>
+        <p:nvSpPr>
+          <p:cNvPr id="32" name="Paso 2"/>
+          <p:cNvSpPr/>
+          <p:nvPr/>
+        </p:nvSpPr>
+        <p:spPr>
+          <a:xfrm>
+            <a:off x="2590495" y="1188720"/>
+            <a:ext cx="1828800" cy="2148840"/>
+          </a:xfrm>
+          <a:prstGeom prst="roundRect">
+            <a:avLst>
+              <a:gd name="adj" fmla="val 5000"/>
+            </a:avLst>
+          </a:prstGeom>
+          <a:solidFill>
+            <a:schemeClr val="bg2"/>
+          </a:solidFill>
+          <a:ln w="12700">
+            <a:solidFill>
+              <a:srgbClr val="DCE4EA"/>
+            </a:solidFill>
+          </a:ln>
+        </p:spPr>
+        <p:txBody>
+          <a:bodyPr rtlCol="0" anchor="ctr"/>
+          <a:lstStyle/>
+          <a:p>
+            <a:pPr algn="ctr"/>
+          </a:p>
+        </p:txBody>
+      </p:sp>
+      <p:sp>
+        <p:nvSpPr>
+          <p:cNvPr id="33" name="Cabecera paso 2"/>
+          <p:cNvSpPr txBox="1"/>
+          <p:nvPr/>
+        </p:nvSpPr>
+        <p:spPr>
+          <a:xfrm>
+            <a:off x="2727655" y="1325880"/>
+            <a:ext cx="1554480" cy="274320"/>
+          </a:xfrm>
+          <a:prstGeom prst="rect">
+            <a:avLst/>
+          </a:prstGeom>
+          <a:noFill/>
+        </p:spPr>
+        <p:txBody>
+          <a:bodyPr wrap="square" lIns="0" rIns="0" tIns="0" bIns="0" anchor="t">
+            <a:spAutoFit/>
+          </a:bodyPr>
+          <a:lstStyle/>
+          <a:p>
+            <a:pPr algn="l"/>
+            <a:r>
+              <a:rPr sz="1400" b="1">
+                <a:solidFill>
+                  <a:schemeClr val="accent1"/>
+                </a:solidFill>
+                <a:latin typeface="Calibri"/>
+              </a:rPr>
+              <a:t>Regla de negocio</a:t>
+            </a:r>
+          </a:p>
+        </p:txBody>
+      </p:sp>
+      <p:sp>
+        <p:nvSpPr>
+          <p:cNvPr id="34" name="Código paso 2"/>
+          <p:cNvSpPr txBox="1"/>
+          <p:nvPr/>
+        </p:nvSpPr>
+        <p:spPr>
+          <a:xfrm>
+            <a:off x="2727655" y="1645920"/>
+            <a:ext cx="1554480" cy="457200"/>
+          </a:xfrm>
+          <a:prstGeom prst="rect">
+            <a:avLst/>
+          </a:prstGeom>
+          <a:noFill/>
+        </p:spPr>
+        <p:txBody>
+          <a:bodyPr wrap="square" lIns="0" rIns="0" tIns="0" bIns="0" anchor="t">
+            <a:spAutoFit/>
+          </a:bodyPr>
+          <a:lstStyle/>
+          <a:p>
+            <a:pPr algn="l"/>
+            <a:r>
+              <a:rPr sz="2400" b="1">
+                <a:solidFill>
+                  <a:schemeClr val="tx2"/>
+                </a:solidFill>
+                <a:latin typeface="Cambria"/>
+              </a:rPr>
+              <a:t>RN-07</a:t>
+            </a:r>
+          </a:p>
+        </p:txBody>
+      </p:sp>
+      <p:sp>
+        <p:nvSpPr>
+          <p:cNvPr id="35" name="Detalle paso 2"/>
+          <p:cNvSpPr txBox="1"/>
+          <p:nvPr/>
+        </p:nvSpPr>
+        <p:spPr>
+          <a:xfrm>
+            <a:off x="2727655" y="2194560"/>
+            <a:ext cx="1554480" cy="1051560"/>
+          </a:xfrm>
+          <a:prstGeom prst="rect">
+            <a:avLst/>
+          </a:prstGeom>
+          <a:noFill/>
+        </p:spPr>
+        <p:txBody>
+          <a:bodyPr wrap="square" lIns="0" rIns="0" tIns="0" bIns="0" anchor="t">
+            <a:spAutoFit/>
+          </a:bodyPr>
+          <a:lstStyle/>
+          <a:p>
+            <a:pPr algn="l"/>
+            <a:r>
+              <a:rPr sz="1400" b="0">
+                <a:solidFill>
+                  <a:schemeClr val="tx2"/>
+                </a:solidFill>
+                <a:latin typeface="Calibri"/>
+              </a:rPr>
+              <a:t>Lo autoriza un administrador distinto del que lo registró</a:t>
+            </a:r>
+          </a:p>
+        </p:txBody>
+      </p:sp>
+      <p:sp>
+        <p:nvSpPr>
+          <p:cNvPr id="36" name="Flecha 2"/>
+          <p:cNvSpPr txBox="1"/>
+          <p:nvPr/>
+        </p:nvSpPr>
+        <p:spPr>
+          <a:xfrm>
+            <a:off x="4419295" y="2080260"/>
+            <a:ext cx="304495" cy="365760"/>
+          </a:xfrm>
+          <a:prstGeom prst="rect">
+            <a:avLst/>
+          </a:prstGeom>
+          <a:noFill/>
+        </p:spPr>
+        <p:txBody>
+          <a:bodyPr wrap="square" lIns="0" rIns="0" tIns="0" bIns="0" anchor="ctr">
+            <a:spAutoFit/>
+          </a:bodyPr>
+          <a:lstStyle/>
+          <a:p>
+            <a:pPr algn="ctr"/>
+            <a:r>
+              <a:rPr sz="2200" b="1">
+                <a:solidFill>
+                  <a:schemeClr val="accent3"/>
+                </a:solidFill>
+                <a:latin typeface="Calibri"/>
+              </a:rPr>
+              <a:t>→</a:t>
+            </a:r>
+          </a:p>
+        </p:txBody>
+      </p:sp>
+      <p:sp>
+        <p:nvSpPr>
+          <p:cNvPr id="37" name="Paso 3"/>
+          <p:cNvSpPr/>
+          <p:nvPr/>
+        </p:nvSpPr>
+        <p:spPr>
+          <a:xfrm>
+            <a:off x="4723790" y="1188720"/>
+            <a:ext cx="1828800" cy="2148840"/>
+          </a:xfrm>
+          <a:prstGeom prst="roundRect">
+            <a:avLst>
+              <a:gd name="adj" fmla="val 5000"/>
+            </a:avLst>
+          </a:prstGeom>
+          <a:solidFill>
+            <a:schemeClr val="bg2"/>
+          </a:solidFill>
+          <a:ln w="12700">
+            <a:solidFill>
+              <a:srgbClr val="DCE4EA"/>
+            </a:solidFill>
+          </a:ln>
+        </p:spPr>
+        <p:txBody>
+          <a:bodyPr rtlCol="0" anchor="ctr"/>
+          <a:lstStyle/>
+          <a:p>
+            <a:pPr algn="ctr"/>
+          </a:p>
+        </p:txBody>
+      </p:sp>
+      <p:sp>
+        <p:nvSpPr>
+          <p:cNvPr id="38" name="Cabecera paso 3"/>
+          <p:cNvSpPr txBox="1"/>
+          <p:nvPr/>
+        </p:nvSpPr>
+        <p:spPr>
+          <a:xfrm>
+            <a:off x="4860950" y="1325880"/>
+            <a:ext cx="1554480" cy="274320"/>
+          </a:xfrm>
+          <a:prstGeom prst="rect">
+            <a:avLst/>
+          </a:prstGeom>
+          <a:noFill/>
+        </p:spPr>
+        <p:txBody>
+          <a:bodyPr wrap="square" lIns="0" rIns="0" tIns="0" bIns="0" anchor="t">
+            <a:spAutoFit/>
+          </a:bodyPr>
+          <a:lstStyle/>
+          <a:p>
+            <a:pPr algn="l"/>
+            <a:r>
+              <a:rPr sz="1400" b="1">
+                <a:solidFill>
+                  <a:schemeClr val="accent1"/>
+                </a:solidFill>
+                <a:latin typeface="Calibri"/>
+              </a:rPr>
+              <a:t>Código</a:t>
+            </a:r>
+          </a:p>
+        </p:txBody>
+      </p:sp>
+      <p:sp>
+        <p:nvSpPr>
+          <p:cNvPr id="39" name="Código paso 3"/>
+          <p:cNvSpPr txBox="1"/>
+          <p:nvPr/>
+        </p:nvSpPr>
+        <p:spPr>
+          <a:xfrm>
+            <a:off x="4860950" y="1645920"/>
+            <a:ext cx="1554480" cy="457200"/>
+          </a:xfrm>
+          <a:prstGeom prst="rect">
+            <a:avLst/>
+          </a:prstGeom>
+          <a:noFill/>
+        </p:spPr>
+        <p:txBody>
+          <a:bodyPr wrap="square" lIns="0" rIns="0" tIns="0" bIns="0" anchor="t">
+            <a:spAutoFit/>
+          </a:bodyPr>
+          <a:lstStyle/>
+          <a:p>
+            <a:pPr algn="l"/>
+            <a:r>
+              <a:rPr sz="2400" b="1">
+                <a:solidFill>
+                  <a:schemeClr val="tx2"/>
+                </a:solidFill>
+                <a:latin typeface="Cambria"/>
+              </a:rPr>
+              <a:t>Autorizar</a:t>
+            </a:r>
+          </a:p>
+        </p:txBody>
+      </p:sp>
+      <p:sp>
+        <p:nvSpPr>
+          <p:cNvPr id="40" name="Detalle paso 3"/>
+          <p:cNvSpPr txBox="1"/>
+          <p:nvPr/>
+        </p:nvSpPr>
+        <p:spPr>
+          <a:xfrm>
+            <a:off x="4860950" y="2194560"/>
+            <a:ext cx="1554480" cy="1051560"/>
+          </a:xfrm>
+          <a:prstGeom prst="rect">
+            <a:avLst/>
+          </a:prstGeom>
+          <a:noFill/>
+        </p:spPr>
+        <p:txBody>
+          <a:bodyPr wrap="square" lIns="0" rIns="0" tIns="0" bIns="0" anchor="t">
+            <a:spAutoFit/>
+          </a:bodyPr>
+          <a:lstStyle/>
+          <a:p>
+            <a:pPr algn="l"/>
+            <a:r>
+              <a:rPr sz="1400" b="0">
+                <a:solidFill>
+                  <a:schemeClr val="tx2"/>
+                </a:solidFill>
+                <a:latin typeface="Calibri"/>
+              </a:rPr>
+              <a:t>Método de ContratosServicio expuesto en la API</a:t>
+            </a:r>
+          </a:p>
+        </p:txBody>
+      </p:sp>
+      <p:sp>
+        <p:nvSpPr>
+          <p:cNvPr id="41" name="Flecha 3"/>
+          <p:cNvSpPr txBox="1"/>
+          <p:nvPr/>
+        </p:nvSpPr>
+        <p:spPr>
+          <a:xfrm>
+            <a:off x="6552590" y="2080260"/>
+            <a:ext cx="304495" cy="365760"/>
+          </a:xfrm>
+          <a:prstGeom prst="rect">
+            <a:avLst/>
+          </a:prstGeom>
+          <a:noFill/>
+        </p:spPr>
+        <p:txBody>
+          <a:bodyPr wrap="square" lIns="0" rIns="0" tIns="0" bIns="0" anchor="ctr">
+            <a:spAutoFit/>
+          </a:bodyPr>
+          <a:lstStyle/>
+          <a:p>
+            <a:pPr algn="ctr"/>
+            <a:r>
+              <a:rPr sz="2200" b="1">
+                <a:solidFill>
+                  <a:schemeClr val="accent3"/>
+                </a:solidFill>
+                <a:latin typeface="Calibri"/>
+              </a:rPr>
+              <a:t>→</a:t>
+            </a:r>
+          </a:p>
+        </p:txBody>
+      </p:sp>
+      <p:sp>
+        <p:nvSpPr>
+          <p:cNvPr id="42" name="Paso 4"/>
+          <p:cNvSpPr/>
+          <p:nvPr/>
+        </p:nvSpPr>
+        <p:spPr>
+          <a:xfrm>
+            <a:off x="6857085" y="1188720"/>
+            <a:ext cx="1828800" cy="2148840"/>
+          </a:xfrm>
+          <a:prstGeom prst="roundRect">
+            <a:avLst>
+              <a:gd name="adj" fmla="val 5000"/>
+            </a:avLst>
+          </a:prstGeom>
+          <a:solidFill>
+            <a:schemeClr val="bg2"/>
+          </a:solidFill>
+          <a:ln w="12700">
+            <a:solidFill>
+              <a:srgbClr val="DCE4EA"/>
+            </a:solidFill>
+          </a:ln>
+        </p:spPr>
+        <p:txBody>
+          <a:bodyPr rtlCol="0" anchor="ctr"/>
+          <a:lstStyle/>
+          <a:p>
+            <a:pPr algn="ctr"/>
+          </a:p>
+        </p:txBody>
+      </p:sp>
+      <p:sp>
+        <p:nvSpPr>
+          <p:cNvPr id="43" name="Cabecera paso 4"/>
+          <p:cNvSpPr txBox="1"/>
+          <p:nvPr/>
+        </p:nvSpPr>
+        <p:spPr>
+          <a:xfrm>
+            <a:off x="6994245" y="1325880"/>
+            <a:ext cx="1554480" cy="274320"/>
+          </a:xfrm>
+          <a:prstGeom prst="rect">
+            <a:avLst/>
+          </a:prstGeom>
+          <a:noFill/>
+        </p:spPr>
+        <p:txBody>
+          <a:bodyPr wrap="square" lIns="0" rIns="0" tIns="0" bIns="0" anchor="t">
+            <a:spAutoFit/>
+          </a:bodyPr>
+          <a:lstStyle/>
+          <a:p>
+            <a:pPr algn="l"/>
+            <a:r>
+              <a:rPr sz="1400" b="1">
+                <a:solidFill>
+                  <a:schemeClr val="accent1"/>
+                </a:solidFill>
+                <a:latin typeface="Calibri"/>
+              </a:rPr>
+              <a:t>Prueba</a:t>
+            </a:r>
+          </a:p>
+        </p:txBody>
+      </p:sp>
+      <p:sp>
+        <p:nvSpPr>
+          <p:cNvPr id="44" name="Código paso 4"/>
+          <p:cNvSpPr txBox="1"/>
+          <p:nvPr/>
+        </p:nvSpPr>
+        <p:spPr>
+          <a:xfrm>
+            <a:off x="6994245" y="1645920"/>
+            <a:ext cx="1554480" cy="457200"/>
+          </a:xfrm>
+          <a:prstGeom prst="rect">
+            <a:avLst/>
+          </a:prstGeom>
+          <a:noFill/>
+        </p:spPr>
+        <p:txBody>
+          <a:bodyPr wrap="square" lIns="0" rIns="0" tIns="0" bIns="0" anchor="t">
+            <a:spAutoFit/>
+          </a:bodyPr>
+          <a:lstStyle/>
+          <a:p>
+            <a:pPr algn="l"/>
+            <a:r>
+              <a:rPr sz="2400" b="1">
+                <a:solidFill>
+                  <a:schemeClr val="tx2"/>
+                </a:solidFill>
+                <a:latin typeface="Cambria"/>
+              </a:rPr>
+              <a:t>xUnit</a:t>
+            </a:r>
+          </a:p>
+        </p:txBody>
+      </p:sp>
+      <p:sp>
+        <p:nvSpPr>
+          <p:cNvPr id="45" name="Detalle paso 4"/>
+          <p:cNvSpPr txBox="1"/>
+          <p:nvPr/>
+        </p:nvSpPr>
+        <p:spPr>
+          <a:xfrm>
+            <a:off x="6994245" y="2194560"/>
+            <a:ext cx="1554480" cy="1051560"/>
+          </a:xfrm>
+          <a:prstGeom prst="rect">
+            <a:avLst/>
+          </a:prstGeom>
+          <a:noFill/>
+        </p:spPr>
+        <p:txBody>
+          <a:bodyPr wrap="square" lIns="0" rIns="0" tIns="0" bIns="0" anchor="t">
+            <a:spAutoFit/>
+          </a:bodyPr>
+          <a:lstStyle/>
+          <a:p>
+            <a:pPr algn="l"/>
+            <a:r>
+              <a:rPr sz="1400" b="0">
+                <a:solidFill>
+                  <a:schemeClr val="tx2"/>
+                </a:solidFill>
+                <a:latin typeface="Calibri"/>
+              </a:rPr>
+              <a:t>Autorizar con el mismo usuario devuelve 400</a:t>
+            </a:r>
+          </a:p>
+        </p:txBody>
+      </p:sp>
+      <p:sp>
+        <p:nvSpPr>
+          <p:cNvPr id="46" name="Mensaje trazabilidad"/>
+          <p:cNvSpPr/>
+          <p:nvPr/>
+        </p:nvSpPr>
+        <p:spPr>
+          <a:xfrm>
+            <a:off x="457200" y="3520440"/>
+            <a:ext cx="8229600" cy="1097280"/>
+          </a:xfrm>
+          <a:prstGeom prst="roundRect">
+            <a:avLst>
+              <a:gd name="adj" fmla="val 8300"/>
+            </a:avLst>
+          </a:prstGeom>
+          <a:solidFill>
+            <a:schemeClr val="accent6"/>
+          </a:solidFill>
+          <a:ln>
+            <a:noFill/>
+          </a:ln>
+        </p:spPr>
+        <p:txBody>
+          <a:bodyPr rtlCol="0" anchor="ctr"/>
+          <a:lstStyle/>
+          <a:p>
+            <a:pPr algn="ctr"/>
+          </a:p>
+        </p:txBody>
+      </p:sp>
+      <p:sp>
+        <p:nvSpPr>
+          <p:cNvPr id="47" name="Texto trazabilidad"/>
+          <p:cNvSpPr txBox="1"/>
+          <p:nvPr/>
+        </p:nvSpPr>
+        <p:spPr>
+          <a:xfrm>
+            <a:off x="731520" y="3520440"/>
+            <a:ext cx="7680960" cy="1097280"/>
+          </a:xfrm>
+          <a:prstGeom prst="rect">
+            <a:avLst/>
+          </a:prstGeom>
+          <a:noFill/>
+        </p:spPr>
+        <p:txBody>
+          <a:bodyPr wrap="square" lIns="0" rIns="0" tIns="0" bIns="0" anchor="ctr">
+            <a:spAutoFit/>
+          </a:bodyPr>
+          <a:lstStyle/>
+          <a:p>
+            <a:pPr algn="l"/>
+            <a:r>
+              <a:rPr sz="1600" b="0">
+                <a:solidFill>
+                  <a:schemeClr val="tx2"/>
+                </a:solidFill>
+                <a:latin typeface="Calibri"/>
+              </a:rPr>
+              <a:t>La cadena también se recorre al revés: desde una prueba se llega a la regla y al requisito que la justifica. Las 15 reglas de negocio tienen al menos una prueba automática.</a:t>
+            </a:r>
+          </a:p>
+        </p:txBody>
+      </p:sp>
+    </p:spTree>
+  </p:cSld>
+  <p:clrMapOvr>
+    <a:masterClrMapping/>
+  </p:clrMapOvr>
+</p:sld>
+</file>
+
+<file path=ppt/slides/slide14.xml><?xml version="1.0" encoding="utf-8"?>
+<p:sld xmlns:a="http://schemas.openxmlformats.org/drawingml/2006/main" xmlns:p="http://schemas.openxmlformats.org/presentationml/2006/main" xmlns:r="http://schemas.openxmlformats.org/officeDocument/2006/relationships">
+  <p:cSld>
+    <p:spTree>
+      <p:nvGrpSpPr>
+        <p:cNvPr id="1" name=""/>
+        <p:cNvGrpSpPr/>
+        <p:nvPr/>
+      </p:nvGrpSpPr>
+      <p:grpSpPr/>
+      <p:sp>
+        <p:nvSpPr>
+          <p:cNvPr id="2" name="Text 1"/>
+          <p:cNvSpPr>
+            <a:spLocks noGrp="1"/>
+          </p:cNvSpPr>
+          <p:nvPr>
+            <p:ph type="title" idx="102" hasCustomPrompt="1"/>
+          </p:nvPr>
+        </p:nvSpPr>
+        <p:spPr>
+          <a:xfrm>
+            <a:off x="457200" y="274320"/>
+            <a:ext cx="7589520" cy="731520"/>
+          </a:xfrm>
+          <a:prstGeom prst="rect">
+            <a:avLst/>
+          </a:prstGeom>
+          <a:noFill/>
+          <a:ln/>
+        </p:spPr>
+        <p:txBody>
+          <a:bodyPr wrap="square" lIns="0" tIns="0" rIns="0" bIns="0" rtlCol="0" anchor="ctr"/>
+          <a:lstStyle/>
+          <a:p>
+            <a:pPr marL="0" indent="0" algn="l">
+              <a:buNone/>
+            </a:pPr>
+            <a:r>
+              <a:rPr lang="en-US" sz="3000" b="1" dirty="0">
+                <a:solidFill>
+                  <a:schemeClr val="tx2"/>
+                </a:solidFill>
+                <a:latin typeface="Cambria" pitchFamily="34" charset="0"/>
+                <a:ea typeface="Cambria" pitchFamily="34" charset="-122"/>
+                <a:cs typeface="Cambria" pitchFamily="34" charset="-120"/>
+              </a:rPr>
+              <a:t>Evidencia: prompts, diffs y criterio humano</a:t>
+            </a:r>
+            <a:endParaRPr lang="en-US" sz="3000" dirty="0"/>
+          </a:p>
+        </p:txBody>
+      </p:sp>
+      <p:sp>
+        <p:nvSpPr>
+          <p:cNvPr id="25" name="Slide Number Placeholder 0"/>
+          <p:cNvSpPr>
+            <a:spLocks noGrp="1"/>
+          </p:cNvSpPr>
+          <p:nvPr>
+            <p:ph type="sldNum" sz="quarter" idx="4294967295"/>
+          </p:nvPr>
+        </p:nvSpPr>
+        <p:spPr>
+          <a:xfrm>
+            <a:off x="8229600" y="4754880"/>
+            <a:ext cx="457200" cy="228600"/>
+          </a:xfrm>
+          <a:prstGeom prst="rect">
+            <a:avLst/>
+          </a:prstGeom>
+          <a:extLst>
+            <a:ext uri="{C572A759-6A51-4108-AA02-DFA0A04FC94B}">
+              <ma14:wrappingTextBoxFlag xmlns:ma14="http://schemas.microsoft.com/office/mac/drawingml/2011/main" xmlns="" val="0"/>
+            </a:ext>
+          </a:extLst>
+        </p:spPr>
+        <p:txBody>
+          <a:bodyPr/>
+          <a:lstStyle>
+            <a:lvl1pPr>
+              <a:defRPr sz="1000">
+                <a:solidFill>
+                  <a:schemeClr val="tx2"/>
+                </a:solidFill>
+              </a:defRPr>
+            </a:lvl1pPr>
+          </a:lstStyle>
+          <a:p>
+            <a:pPr algn="r"/>
+            <a:fld id="{F7021451-1387-4CA6-816F-3879F97B5CBC}" type="slidenum">
+              <a:rPr lang="en-US" b="0"/>
+              <a:t>10</a:t>
+            </a:fld>
+            <a:endParaRPr lang="en-US"/>
+          </a:p>
+        </p:txBody>
+      </p:sp>
+      <p:sp>
+        <p:nvSpPr>
+          <p:cNvPr id="26" name="Etiqueta de sección"/>
+          <p:cNvSpPr txBox="1"/>
+          <p:nvPr/>
+        </p:nvSpPr>
+        <p:spPr>
+          <a:xfrm>
+            <a:off x="457200" y="91440"/>
+            <a:ext cx="7863840" cy="228600"/>
+          </a:xfrm>
+          <a:prstGeom prst="rect">
+            <a:avLst/>
+          </a:prstGeom>
+          <a:noFill/>
+        </p:spPr>
+        <p:txBody>
+          <a:bodyPr wrap="square" lIns="0" rIns="0" tIns="0" bIns="0" anchor="ctr">
+            <a:spAutoFit/>
+          </a:bodyPr>
+          <a:lstStyle/>
+          <a:p>
+            <a:pPr algn="l"/>
+            <a:r>
+              <a:rPr sz="1100" b="1">
+                <a:solidFill>
+                  <a:schemeClr val="accent1"/>
+                </a:solidFill>
+                <a:latin typeface="Calibri"/>
+              </a:rPr>
+              <a:t>4 · INTELIGENCIA ARTIFICIAL Y EVIDENCIA DE REVISIÓN</a:t>
+            </a:r>
+          </a:p>
+        </p:txBody>
+      </p:sp>
+      <p:sp>
+        <p:nvSpPr>
+          <p:cNvPr id="27" name="Evidencia 1"/>
+          <p:cNvSpPr/>
+          <p:nvPr/>
+        </p:nvSpPr>
+        <p:spPr>
+          <a:xfrm>
+            <a:off x="457200" y="1097280"/>
+            <a:ext cx="8229600" cy="1097280"/>
+          </a:xfrm>
+          <a:prstGeom prst="roundRect">
+            <a:avLst>
+              <a:gd name="adj" fmla="val 5000"/>
+            </a:avLst>
+          </a:prstGeom>
+          <a:solidFill>
+            <a:schemeClr val="bg2"/>
+          </a:solidFill>
+          <a:ln w="12700">
+            <a:solidFill>
+              <a:srgbClr val="DCE4EA"/>
+            </a:solidFill>
+          </a:ln>
+        </p:spPr>
+        <p:txBody>
+          <a:bodyPr rtlCol="0" anchor="ctr"/>
+          <a:lstStyle/>
+          <a:p>
+            <a:pPr algn="ctr"/>
+          </a:p>
+        </p:txBody>
+      </p:sp>
+      <p:sp>
+        <p:nvSpPr>
+          <p:cNvPr id="28" name="Número 1"/>
+          <p:cNvSpPr/>
+          <p:nvPr/>
+        </p:nvSpPr>
+        <p:spPr>
+          <a:xfrm>
+            <a:off x="640080" y="1417319"/>
+            <a:ext cx="457200" cy="457200"/>
+          </a:xfrm>
+          <a:prstGeom prst="ellipse">
+            <a:avLst/>
+          </a:prstGeom>
+          <a:solidFill>
+            <a:srgbClr val="DCE9F1"/>
+          </a:solidFill>
+          <a:ln>
+            <a:noFill/>
+          </a:ln>
+        </p:spPr>
+        <p:txBody>
+          <a:bodyPr rtlCol="0" anchor="ctr"/>
+          <a:lstStyle/>
+          <a:p>
+            <a:pPr algn="ctr"/>
+          </a:p>
+        </p:txBody>
+      </p:sp>
+      <p:sp>
+        <p:nvSpPr>
+          <p:cNvPr id="29" name="Texto número 1"/>
+          <p:cNvSpPr txBox="1"/>
+          <p:nvPr/>
+        </p:nvSpPr>
+        <p:spPr>
+          <a:xfrm>
+            <a:off x="640080" y="1417319"/>
+            <a:ext cx="457200" cy="457200"/>
+          </a:xfrm>
+          <a:prstGeom prst="rect">
+            <a:avLst/>
+          </a:prstGeom>
+          <a:noFill/>
+        </p:spPr>
+        <p:txBody>
+          <a:bodyPr wrap="square" lIns="0" rIns="0" tIns="0" bIns="0" anchor="ctr">
+            <a:spAutoFit/>
+          </a:bodyPr>
+          <a:lstStyle/>
+          <a:p>
+            <a:pPr algn="ctr"/>
+            <a:r>
+              <a:rPr sz="1800" b="1">
+                <a:solidFill>
+                  <a:schemeClr val="tx2"/>
+                </a:solidFill>
+                <a:latin typeface="Cambria"/>
+              </a:rPr>
+              <a:t>1</a:t>
+            </a:r>
+          </a:p>
+        </p:txBody>
+      </p:sp>
+      <p:sp>
+        <p:nvSpPr>
+          <p:cNvPr id="30" name="Entrada 1"/>
+          <p:cNvSpPr txBox="1"/>
+          <p:nvPr/>
+        </p:nvSpPr>
+        <p:spPr>
+          <a:xfrm>
+            <a:off x="1280160" y="1188720"/>
+            <a:ext cx="3474720" cy="914400"/>
+          </a:xfrm>
+          <a:prstGeom prst="rect">
+            <a:avLst/>
+          </a:prstGeom>
+          <a:noFill/>
+        </p:spPr>
+        <p:txBody>
+          <a:bodyPr wrap="square" lIns="0" rIns="0" tIns="0" bIns="0" anchor="ctr">
+            <a:spAutoFit/>
+          </a:bodyPr>
+          <a:lstStyle/>
+          <a:p>
+            <a:pPr algn="l"/>
+            <a:r>
+              <a:rPr sz="1400" b="1">
+                <a:solidFill>
+                  <a:schemeClr val="tx2"/>
+                </a:solidFill>
+                <a:latin typeface="Calibri"/>
+              </a:rPr>
+              <a:t>Prompt, fase 2: </a:t>
+            </a:r>
+            <a:r>
+              <a:rPr sz="1400" b="0">
+                <a:solidFill>
+                  <a:schemeClr val="tx2"/>
+                </a:solidFill>
+                <a:latin typeface="Calibri"/>
+              </a:rPr>
+              <a:t>«Usa user-secrets y variables de entorno; estos valores nunca deben subirse a GitHub.»</a:t>
+            </a:r>
+          </a:p>
+        </p:txBody>
+      </p:sp>
+      <p:sp>
+        <p:nvSpPr>
+          <p:cNvPr id="31" name="Resultado 1"/>
+          <p:cNvSpPr txBox="1"/>
+          <p:nvPr/>
+        </p:nvSpPr>
+        <p:spPr>
+          <a:xfrm>
+            <a:off x="4937760" y="1188720"/>
+            <a:ext cx="3566160" cy="914400"/>
+          </a:xfrm>
+          <a:prstGeom prst="rect">
+            <a:avLst/>
+          </a:prstGeom>
+          <a:noFill/>
+        </p:spPr>
+        <p:txBody>
+          <a:bodyPr wrap="square" lIns="0" rIns="0" tIns="0" bIns="0" anchor="ctr">
+            <a:spAutoFit/>
+          </a:bodyPr>
+          <a:lstStyle/>
+          <a:p>
+            <a:pPr algn="l"/>
+            <a:r>
+              <a:rPr sz="1400" b="1">
+                <a:solidFill>
+                  <a:schemeClr val="tx2"/>
+                </a:solidFill>
+                <a:latin typeface="Calibri"/>
+              </a:rPr>
+              <a:t>Diff 0c6a73c: </a:t>
+            </a:r>
+            <a:r>
+              <a:rPr sz="1400" b="0">
+                <a:solidFill>
+                  <a:schemeClr val="tx2"/>
+                </a:solidFill>
+                <a:latin typeface="Calibri"/>
+              </a:rPr>
+              <a:t>login JWT y 18 pruebas. El humano impuso la restricción de seguridad antes del código.</a:t>
+            </a:r>
+          </a:p>
+        </p:txBody>
+      </p:sp>
+      <p:sp>
+        <p:nvSpPr>
+          <p:cNvPr id="32" name="Evidencia 2"/>
+          <p:cNvSpPr/>
+          <p:nvPr/>
+        </p:nvSpPr>
+        <p:spPr>
+          <a:xfrm>
+            <a:off x="457200" y="2286000"/>
+            <a:ext cx="8229600" cy="1097280"/>
+          </a:xfrm>
+          <a:prstGeom prst="roundRect">
+            <a:avLst>
+              <a:gd name="adj" fmla="val 5000"/>
+            </a:avLst>
+          </a:prstGeom>
+          <a:solidFill>
+            <a:schemeClr val="bg2"/>
+          </a:solidFill>
+          <a:ln w="12700">
+            <a:solidFill>
+              <a:srgbClr val="DCE4EA"/>
+            </a:solidFill>
+          </a:ln>
+        </p:spPr>
+        <p:txBody>
+          <a:bodyPr rtlCol="0" anchor="ctr"/>
+          <a:lstStyle/>
+          <a:p>
+            <a:pPr algn="ctr"/>
+          </a:p>
+        </p:txBody>
+      </p:sp>
+      <p:sp>
+        <p:nvSpPr>
+          <p:cNvPr id="33" name="Número 2"/>
+          <p:cNvSpPr/>
+          <p:nvPr/>
+        </p:nvSpPr>
+        <p:spPr>
+          <a:xfrm>
+            <a:off x="640080" y="2606040"/>
+            <a:ext cx="457200" cy="457200"/>
+          </a:xfrm>
+          <a:prstGeom prst="ellipse">
+            <a:avLst/>
+          </a:prstGeom>
+          <a:solidFill>
+            <a:srgbClr val="DCE9F1"/>
+          </a:solidFill>
+          <a:ln>
+            <a:noFill/>
+          </a:ln>
+        </p:spPr>
+        <p:txBody>
+          <a:bodyPr rtlCol="0" anchor="ctr"/>
+          <a:lstStyle/>
+          <a:p>
+            <a:pPr algn="ctr"/>
+          </a:p>
+        </p:txBody>
+      </p:sp>
+      <p:sp>
+        <p:nvSpPr>
+          <p:cNvPr id="34" name="Texto número 2"/>
+          <p:cNvSpPr txBox="1"/>
+          <p:nvPr/>
+        </p:nvSpPr>
+        <p:spPr>
+          <a:xfrm>
+            <a:off x="640080" y="2606040"/>
+            <a:ext cx="457200" cy="457200"/>
+          </a:xfrm>
+          <a:prstGeom prst="rect">
+            <a:avLst/>
+          </a:prstGeom>
+          <a:noFill/>
+        </p:spPr>
+        <p:txBody>
+          <a:bodyPr wrap="square" lIns="0" rIns="0" tIns="0" bIns="0" anchor="ctr">
+            <a:spAutoFit/>
+          </a:bodyPr>
+          <a:lstStyle/>
+          <a:p>
+            <a:pPr algn="ctr"/>
+            <a:r>
+              <a:rPr sz="1800" b="1">
+                <a:solidFill>
+                  <a:schemeClr val="tx2"/>
+                </a:solidFill>
+                <a:latin typeface="Cambria"/>
+              </a:rPr>
+              <a:t>2</a:t>
+            </a:r>
+          </a:p>
+        </p:txBody>
+      </p:sp>
+      <p:sp>
+        <p:nvSpPr>
+          <p:cNvPr id="35" name="Entrada 2"/>
+          <p:cNvSpPr txBox="1"/>
+          <p:nvPr/>
+        </p:nvSpPr>
+        <p:spPr>
+          <a:xfrm>
+            <a:off x="1280160" y="2377440"/>
+            <a:ext cx="3474720" cy="914400"/>
+          </a:xfrm>
+          <a:prstGeom prst="rect">
+            <a:avLst/>
+          </a:prstGeom>
+          <a:noFill/>
+        </p:spPr>
+        <p:txBody>
+          <a:bodyPr wrap="square" lIns="0" rIns="0" tIns="0" bIns="0" anchor="ctr">
+            <a:spAutoFit/>
+          </a:bodyPr>
+          <a:lstStyle/>
+          <a:p>
+            <a:pPr algn="l"/>
+            <a:r>
+              <a:rPr sz="1400" b="1">
+                <a:solidFill>
+                  <a:schemeClr val="tx2"/>
+                </a:solidFill>
+                <a:latin typeface="Calibri"/>
+              </a:rPr>
+              <a:t>Prompt, decisión técnica: </a:t>
+            </a:r>
+            <a:r>
+              <a:rPr sz="1400" b="0">
+                <a:solidFill>
+                  <a:schemeClr val="tx2"/>
+                </a:solidFill>
+                <a:latin typeface="Calibri"/>
+              </a:rPr>
+              <a:t>«¿Qué elección sería más óptima, Vitest o Karma?»</a:t>
+            </a:r>
+          </a:p>
+        </p:txBody>
+      </p:sp>
+      <p:sp>
+        <p:nvSpPr>
+          <p:cNvPr id="36" name="Resultado 2"/>
+          <p:cNvSpPr txBox="1"/>
+          <p:nvPr/>
+        </p:nvSpPr>
+        <p:spPr>
+          <a:xfrm>
+            <a:off x="4937760" y="2377440"/>
+            <a:ext cx="3566160" cy="914400"/>
+          </a:xfrm>
+          <a:prstGeom prst="rect">
+            <a:avLst/>
+          </a:prstGeom>
+          <a:noFill/>
+        </p:spPr>
+        <p:txBody>
+          <a:bodyPr wrap="square" lIns="0" rIns="0" tIns="0" bIns="0" anchor="ctr">
+            <a:spAutoFit/>
+          </a:bodyPr>
+          <a:lstStyle/>
+          <a:p>
+            <a:pPr algn="l"/>
+            <a:r>
+              <a:rPr sz="1400" b="1">
+                <a:solidFill>
+                  <a:schemeClr val="tx2"/>
+                </a:solidFill>
+                <a:latin typeface="Calibri"/>
+              </a:rPr>
+              <a:t>Criterio humano: </a:t>
+            </a:r>
+            <a:r>
+              <a:rPr sz="1400" b="0">
+                <a:solidFill>
+                  <a:schemeClr val="tx2"/>
+                </a:solidFill>
+                <a:latin typeface="Calibri"/>
+              </a:rPr>
+              <a:t>la IA comparó esfuerzo y tokens; el humano decidió usar Vitest.</a:t>
+            </a:r>
+          </a:p>
+        </p:txBody>
+      </p:sp>
+      <p:sp>
+        <p:nvSpPr>
+          <p:cNvPr id="37" name="Evidencia 3"/>
+          <p:cNvSpPr/>
+          <p:nvPr/>
+        </p:nvSpPr>
+        <p:spPr>
+          <a:xfrm>
+            <a:off x="457200" y="3474720"/>
+            <a:ext cx="8229600" cy="1097280"/>
+          </a:xfrm>
+          <a:prstGeom prst="roundRect">
+            <a:avLst>
+              <a:gd name="adj" fmla="val 5000"/>
+            </a:avLst>
+          </a:prstGeom>
+          <a:solidFill>
+            <a:schemeClr val="bg2"/>
+          </a:solidFill>
+          <a:ln w="12700">
+            <a:solidFill>
+              <a:srgbClr val="DCE4EA"/>
+            </a:solidFill>
+          </a:ln>
+        </p:spPr>
+        <p:txBody>
+          <a:bodyPr rtlCol="0" anchor="ctr"/>
+          <a:lstStyle/>
+          <a:p>
+            <a:pPr algn="ctr"/>
+          </a:p>
+        </p:txBody>
+      </p:sp>
+      <p:sp>
+        <p:nvSpPr>
+          <p:cNvPr id="38" name="Número 3"/>
+          <p:cNvSpPr/>
+          <p:nvPr/>
+        </p:nvSpPr>
+        <p:spPr>
+          <a:xfrm>
+            <a:off x="640080" y="3794759"/>
+            <a:ext cx="457200" cy="457200"/>
+          </a:xfrm>
+          <a:prstGeom prst="ellipse">
+            <a:avLst/>
+          </a:prstGeom>
+          <a:solidFill>
+            <a:srgbClr val="DCE9F1"/>
+          </a:solidFill>
+          <a:ln>
+            <a:noFill/>
+          </a:ln>
+        </p:spPr>
+        <p:txBody>
+          <a:bodyPr rtlCol="0" anchor="ctr"/>
+          <a:lstStyle/>
+          <a:p>
+            <a:pPr algn="ctr"/>
+          </a:p>
+        </p:txBody>
+      </p:sp>
+      <p:sp>
+        <p:nvSpPr>
+          <p:cNvPr id="39" name="Texto número 3"/>
+          <p:cNvSpPr txBox="1"/>
+          <p:nvPr/>
+        </p:nvSpPr>
+        <p:spPr>
+          <a:xfrm>
+            <a:off x="640080" y="3794759"/>
+            <a:ext cx="457200" cy="457200"/>
+          </a:xfrm>
+          <a:prstGeom prst="rect">
+            <a:avLst/>
+          </a:prstGeom>
+          <a:noFill/>
+        </p:spPr>
+        <p:txBody>
+          <a:bodyPr wrap="square" lIns="0" rIns="0" tIns="0" bIns="0" anchor="ctr">
+            <a:spAutoFit/>
+          </a:bodyPr>
+          <a:lstStyle/>
+          <a:p>
+            <a:pPr algn="ctr"/>
+            <a:r>
+              <a:rPr sz="1800" b="1">
+                <a:solidFill>
+                  <a:schemeClr val="tx2"/>
+                </a:solidFill>
+                <a:latin typeface="Cambria"/>
+              </a:rPr>
+              <a:t>3</a:t>
+            </a:r>
+          </a:p>
+        </p:txBody>
+      </p:sp>
+      <p:sp>
+        <p:nvSpPr>
+          <p:cNvPr id="40" name="Entrada 3"/>
+          <p:cNvSpPr txBox="1"/>
+          <p:nvPr/>
+        </p:nvSpPr>
+        <p:spPr>
+          <a:xfrm>
+            <a:off x="1280160" y="3566160"/>
+            <a:ext cx="3474720" cy="914400"/>
+          </a:xfrm>
+          <a:prstGeom prst="rect">
+            <a:avLst/>
+          </a:prstGeom>
+          <a:noFill/>
+        </p:spPr>
+        <p:txBody>
+          <a:bodyPr wrap="square" lIns="0" rIns="0" tIns="0" bIns="0" anchor="ctr">
+            <a:spAutoFit/>
+          </a:bodyPr>
+          <a:lstStyle/>
+          <a:p>
+            <a:pPr algn="l"/>
+            <a:r>
+              <a:rPr sz="1400" b="1">
+                <a:solidFill>
+                  <a:schemeClr val="tx2"/>
+                </a:solidFill>
+                <a:latin typeface="Calibri"/>
+              </a:rPr>
+              <a:t>Diff 747cce4: </a:t>
+            </a:r>
+            <a:r>
+              <a:rPr sz="1400" b="0">
+                <a:solidFill>
+                  <a:schemeClr val="tx2"/>
+                </a:solidFill>
+                <a:latin typeface="Calibri"/>
+              </a:rPr>
+              <a:t>Tablas.sql con +238 y −47 líneas; la IA corrigió el script de base de datos.</a:t>
+            </a:r>
+          </a:p>
+        </p:txBody>
+      </p:sp>
+      <p:sp>
+        <p:nvSpPr>
+          <p:cNvPr id="41" name="Resultado 3"/>
+          <p:cNvSpPr txBox="1"/>
+          <p:nvPr/>
+        </p:nvSpPr>
+        <p:spPr>
+          <a:xfrm>
+            <a:off x="4937760" y="3566160"/>
+            <a:ext cx="3566160" cy="914400"/>
+          </a:xfrm>
+          <a:prstGeom prst="rect">
+            <a:avLst/>
+          </a:prstGeom>
+          <a:noFill/>
+        </p:spPr>
+        <p:txBody>
+          <a:bodyPr wrap="square" lIns="0" rIns="0" tIns="0" bIns="0" anchor="ctr">
+            <a:spAutoFit/>
+          </a:bodyPr>
+          <a:lstStyle/>
+          <a:p>
+            <a:pPr algn="l"/>
+            <a:r>
+              <a:rPr sz="1400" b="1">
+                <a:solidFill>
+                  <a:schemeClr val="tx2"/>
+                </a:solidFill>
+                <a:latin typeface="Calibri"/>
+              </a:rPr>
+              <a:t>Revisión: </a:t>
+            </a:r>
+            <a:r>
+              <a:rPr sz="1400" b="0">
+                <a:solidFill>
+                  <a:schemeClr val="tx2"/>
+                </a:solidFill>
+                <a:latin typeface="Calibri"/>
+              </a:rPr>
+              <a:t>se ejecutó Instalar.sql en SQL Server antes de generar código; lo mal subido se revirtió.</a:t>
+            </a:r>
+          </a:p>
+        </p:txBody>
+      </p:sp>
+    </p:spTree>
+  </p:cSld>
+  <p:clrMapOvr>
+    <a:masterClrMapping/>
+  </p:clrMapOvr>
+</p:sld>
+</file>
+
+<file path=ppt/slides/slide15.xml><?xml version="1.0" encoding="utf-8"?>
+<p:sld xmlns:a="http://schemas.openxmlformats.org/drawingml/2006/main" xmlns:p="http://schemas.openxmlformats.org/presentationml/2006/main" xmlns:r="http://schemas.openxmlformats.org/officeDocument/2006/relationships">
+  <p:cSld>
+    <p:spTree>
+      <p:nvGrpSpPr>
+        <p:cNvPr id="1" name=""/>
+        <p:cNvGrpSpPr/>
+        <p:nvPr/>
+      </p:nvGrpSpPr>
+      <p:grpSpPr/>
+      <p:sp>
+        <p:nvSpPr>
+          <p:cNvPr id="2" name="Text 1"/>
+          <p:cNvSpPr>
+            <a:spLocks noGrp="1"/>
+          </p:cNvSpPr>
+          <p:nvPr>
+            <p:ph type="title" idx="102" hasCustomPrompt="1"/>
+          </p:nvPr>
+        </p:nvSpPr>
+        <p:spPr>
+          <a:xfrm>
+            <a:off x="457200" y="274320"/>
+            <a:ext cx="7589520" cy="731520"/>
+          </a:xfrm>
+          <a:prstGeom prst="rect">
+            <a:avLst/>
+          </a:prstGeom>
+          <a:noFill/>
+          <a:ln/>
+        </p:spPr>
+        <p:txBody>
+          <a:bodyPr wrap="square" lIns="0" tIns="0" rIns="0" bIns="0" rtlCol="0" anchor="ctr"/>
+          <a:lstStyle/>
+          <a:p>
+            <a:pPr marL="0" indent="0" algn="l">
+              <a:buNone/>
+            </a:pPr>
+            <a:r>
+              <a:rPr lang="en-US" sz="3000" b="1" dirty="0">
+                <a:solidFill>
+                  <a:schemeClr val="tx2"/>
+                </a:solidFill>
+                <a:latin typeface="Cambria" pitchFamily="34" charset="0"/>
+                <a:ea typeface="Cambria" pitchFamily="34" charset="-122"/>
+                <a:cs typeface="Cambria" pitchFamily="34" charset="-120"/>
+              </a:rPr>
+              <a:t>Demo: API documentada y reglas en acción</a:t>
+            </a:r>
+            <a:endParaRPr lang="en-US" sz="3000" dirty="0"/>
+          </a:p>
+        </p:txBody>
+      </p:sp>
+      <p:sp>
+        <p:nvSpPr>
+          <p:cNvPr id="25" name="Slide Number Placeholder 0"/>
+          <p:cNvSpPr>
+            <a:spLocks noGrp="1"/>
+          </p:cNvSpPr>
+          <p:nvPr>
+            <p:ph type="sldNum" sz="quarter" idx="4294967295"/>
+          </p:nvPr>
+        </p:nvSpPr>
+        <p:spPr>
+          <a:xfrm>
+            <a:off x="8229600" y="4754880"/>
+            <a:ext cx="457200" cy="228600"/>
+          </a:xfrm>
+          <a:prstGeom prst="rect">
+            <a:avLst/>
+          </a:prstGeom>
+          <a:extLst>
+            <a:ext uri="{C572A759-6A51-4108-AA02-DFA0A04FC94B}">
+              <ma14:wrappingTextBoxFlag xmlns:ma14="http://schemas.microsoft.com/office/mac/drawingml/2011/main" xmlns="" val="0"/>
+            </a:ext>
+          </a:extLst>
+        </p:spPr>
+        <p:txBody>
+          <a:bodyPr/>
+          <a:lstStyle>
+            <a:lvl1pPr>
+              <a:defRPr sz="1000">
+                <a:solidFill>
+                  <a:schemeClr val="tx2"/>
+                </a:solidFill>
+              </a:defRPr>
+            </a:lvl1pPr>
+          </a:lstStyle>
+          <a:p>
+            <a:pPr algn="r"/>
+            <a:fld id="{F7021451-1387-4CA6-816F-3879F97B5CBC}" type="slidenum">
+              <a:rPr lang="en-US" b="0"/>
               <a:t>12</a:t>
             </a:fld>
             <a:endParaRPr lang="en-US"/>
+          </a:p>
+        </p:txBody>
+      </p:sp>
+      <p:sp>
+        <p:nvSpPr>
+          <p:cNvPr id="26" name="Etiqueta de sección"/>
+          <p:cNvSpPr txBox="1"/>
+          <p:nvPr/>
+        </p:nvSpPr>
+        <p:spPr>
+          <a:xfrm>
+            <a:off x="457200" y="91440"/>
+            <a:ext cx="7863840" cy="228600"/>
+          </a:xfrm>
+          <a:prstGeom prst="rect">
+            <a:avLst/>
+          </a:prstGeom>
+          <a:noFill/>
+        </p:spPr>
+        <p:txBody>
+          <a:bodyPr wrap="square" lIns="0" rIns="0" tIns="0" bIns="0" anchor="ctr">
+            <a:spAutoFit/>
+          </a:bodyPr>
+          <a:lstStyle/>
+          <a:p>
+            <a:pPr algn="l"/>
+            <a:r>
+              <a:rPr sz="1100" b="1">
+                <a:solidFill>
+                  <a:schemeClr val="accent1"/>
+                </a:solidFill>
+                <a:latin typeface="Calibri"/>
+              </a:rPr>
+              <a:t>5 · DEMOSTRACIÓN FUNCIONAL</a:t>
+            </a:r>
+          </a:p>
+        </p:txBody>
+      </p:sp>
+      <p:sp>
+        <p:nvSpPr>
+          <p:cNvPr id="27" name="Tarjeta endpoints"/>
+          <p:cNvSpPr/>
+          <p:nvPr/>
+        </p:nvSpPr>
+        <p:spPr>
+          <a:xfrm>
+            <a:off x="457200" y="1143000"/>
+            <a:ext cx="4023360" cy="2606040"/>
+          </a:xfrm>
+          <a:prstGeom prst="roundRect">
+            <a:avLst>
+              <a:gd name="adj" fmla="val 5000"/>
+            </a:avLst>
+          </a:prstGeom>
+          <a:solidFill>
+            <a:schemeClr val="bg2"/>
+          </a:solidFill>
+          <a:ln w="12700">
+            <a:solidFill>
+              <a:srgbClr val="DCE4EA"/>
+            </a:solidFill>
+          </a:ln>
+        </p:spPr>
+        <p:txBody>
+          <a:bodyPr rtlCol="0" anchor="ctr"/>
+          <a:lstStyle/>
+          <a:p>
+            <a:pPr algn="ctr"/>
+          </a:p>
+        </p:txBody>
+      </p:sp>
+      <p:sp>
+        <p:nvSpPr>
+          <p:cNvPr id="28" name="Título endpoints"/>
+          <p:cNvSpPr txBox="1"/>
+          <p:nvPr/>
+        </p:nvSpPr>
+        <p:spPr>
+          <a:xfrm>
+            <a:off x="640080" y="1280160"/>
+            <a:ext cx="3657600" cy="365760"/>
+          </a:xfrm>
+          <a:prstGeom prst="rect">
+            <a:avLst/>
+          </a:prstGeom>
+          <a:noFill/>
+        </p:spPr>
+        <p:txBody>
+          <a:bodyPr wrap="square" lIns="0" rIns="0" tIns="0" bIns="0" anchor="t">
+            <a:spAutoFit/>
+          </a:bodyPr>
+          <a:lstStyle/>
+          <a:p>
+            <a:pPr algn="l"/>
+            <a:r>
+              <a:rPr sz="1800" b="1">
+                <a:solidFill>
+                  <a:schemeClr val="tx2"/>
+                </a:solidFill>
+                <a:latin typeface="Calibri"/>
+              </a:rPr>
+              <a:t>Endpoints principales (OpenAPI)</a:t>
+            </a:r>
+          </a:p>
+        </p:txBody>
+      </p:sp>
+      <p:sp>
+        <p:nvSpPr>
+          <p:cNvPr id="29" name="Lista endpoints"/>
+          <p:cNvSpPr txBox="1"/>
+          <p:nvPr/>
+        </p:nvSpPr>
+        <p:spPr>
+          <a:xfrm>
+            <a:off x="640080" y="1737360"/>
+            <a:ext cx="3657600" cy="1920240"/>
+          </a:xfrm>
+          <a:prstGeom prst="rect">
+            <a:avLst/>
+          </a:prstGeom>
+          <a:noFill/>
+        </p:spPr>
+        <p:txBody>
+          <a:bodyPr wrap="square" lIns="0" rIns="0" tIns="0" bIns="0" anchor="t">
+            <a:spAutoFit/>
+          </a:bodyPr>
+          <a:lstStyle/>
+          <a:p>
+            <a:pPr algn="l"/>
+            <a:r>
+              <a:rPr sz="1400" b="0">
+                <a:solidFill>
+                  <a:schemeClr val="tx2"/>
+                </a:solidFill>
+                <a:latin typeface="Calibri"/>
+              </a:rPr>
+              <a:t>POST /api/auth/login</a:t>
+            </a:r>
+          </a:p>
+          <a:p>
+            <a:pPr algn="l">
+              <a:spcBef>
+                <a:spcPts val="600"/>
+              </a:spcBef>
+            </a:pPr>
+            <a:r>
+              <a:rPr sz="1400" b="0">
+                <a:solidFill>
+                  <a:schemeClr val="tx2"/>
+                </a:solidFill>
+                <a:latin typeface="Calibri"/>
+              </a:rPr>
+              <a:t>GET · POST · PUT · DELETE /api/clientes</a:t>
+            </a:r>
+          </a:p>
+          <a:p>
+            <a:pPr algn="l">
+              <a:spcBef>
+                <a:spcPts val="600"/>
+              </a:spcBef>
+            </a:pPr>
+            <a:r>
+              <a:rPr sz="1400" b="0">
+                <a:solidFill>
+                  <a:schemeClr val="tx2"/>
+                </a:solidFill>
+                <a:latin typeface="Calibri"/>
+              </a:rPr>
+              <a:t>POST /api/contratos/{id}/autorizar</a:t>
+            </a:r>
+          </a:p>
+          <a:p>
+            <a:pPr algn="l">
+              <a:spcBef>
+                <a:spcPts val="600"/>
+              </a:spcBef>
+            </a:pPr>
+            <a:r>
+              <a:rPr sz="1400" b="0">
+                <a:solidFill>
+                  <a:schemeClr val="tx2"/>
+                </a:solidFill>
+                <a:latin typeface="Calibri"/>
+              </a:rPr>
+              <a:t>POST /api/pagos · /api/pagos/{id}/anular</a:t>
+            </a:r>
+          </a:p>
+          <a:p>
+            <a:pPr algn="l">
+              <a:spcBef>
+                <a:spcPts val="600"/>
+              </a:spcBef>
+            </a:pPr>
+            <a:r>
+              <a:rPr sz="1400" b="0">
+                <a:solidFill>
+                  <a:schemeClr val="tx2"/>
+                </a:solidFill>
+                <a:latin typeface="Calibri"/>
+              </a:rPr>
+              <a:t>GET /api/analiticas/resumen</a:t>
+            </a:r>
+          </a:p>
+        </p:txBody>
+      </p:sp>
+      <p:sp>
+        <p:nvSpPr>
+          <p:cNvPr id="30" name="Tarjeta reglas"/>
+          <p:cNvSpPr/>
+          <p:nvPr/>
+        </p:nvSpPr>
+        <p:spPr>
+          <a:xfrm>
+            <a:off x="4663440" y="1143000"/>
+            <a:ext cx="4023360" cy="2606040"/>
+          </a:xfrm>
+          <a:prstGeom prst="roundRect">
+            <a:avLst>
+              <a:gd name="adj" fmla="val 5000"/>
+            </a:avLst>
+          </a:prstGeom>
+          <a:solidFill>
+            <a:schemeClr val="bg2"/>
+          </a:solidFill>
+          <a:ln w="12700">
+            <a:solidFill>
+              <a:srgbClr val="DCE4EA"/>
+            </a:solidFill>
+          </a:ln>
+        </p:spPr>
+        <p:txBody>
+          <a:bodyPr rtlCol="0" anchor="ctr"/>
+          <a:lstStyle/>
+          <a:p>
+            <a:pPr algn="ctr"/>
+          </a:p>
+        </p:txBody>
+      </p:sp>
+      <p:sp>
+        <p:nvSpPr>
+          <p:cNvPr id="31" name="Título reglas"/>
+          <p:cNvSpPr txBox="1"/>
+          <p:nvPr/>
+        </p:nvSpPr>
+        <p:spPr>
+          <a:xfrm>
+            <a:off x="4846320" y="1280160"/>
+            <a:ext cx="3657600" cy="365760"/>
+          </a:xfrm>
+          <a:prstGeom prst="rect">
+            <a:avLst/>
+          </a:prstGeom>
+          <a:noFill/>
+        </p:spPr>
+        <p:txBody>
+          <a:bodyPr wrap="square" lIns="0" rIns="0" tIns="0" bIns="0" anchor="t">
+            <a:spAutoFit/>
+          </a:bodyPr>
+          <a:lstStyle/>
+          <a:p>
+            <a:pPr algn="l"/>
+            <a:r>
+              <a:rPr sz="1800" b="1">
+                <a:solidFill>
+                  <a:schemeClr val="tx2"/>
+                </a:solidFill>
+                <a:latin typeface="Calibri"/>
+              </a:rPr>
+              <a:t>CRUD con reglas de negocio</a:t>
+            </a:r>
+          </a:p>
+        </p:txBody>
+      </p:sp>
+      <p:sp>
+        <p:nvSpPr>
+          <p:cNvPr id="32" name="Lista reglas"/>
+          <p:cNvSpPr txBox="1"/>
+          <p:nvPr/>
+        </p:nvSpPr>
+        <p:spPr>
+          <a:xfrm>
+            <a:off x="4846320" y="1737360"/>
+            <a:ext cx="3657600" cy="1920240"/>
+          </a:xfrm>
+          <a:prstGeom prst="rect">
+            <a:avLst/>
+          </a:prstGeom>
+          <a:noFill/>
+        </p:spPr>
+        <p:txBody>
+          <a:bodyPr wrap="square" lIns="0" rIns="0" tIns="0" bIns="0" anchor="t">
+            <a:spAutoFit/>
+          </a:bodyPr>
+          <a:lstStyle/>
+          <a:p>
+            <a:pPr algn="l"/>
+            <a:r>
+              <a:rPr sz="1400" b="0">
+                <a:solidFill>
+                  <a:schemeClr val="tx2"/>
+                </a:solidFill>
+                <a:latin typeface="Calibri"/>
+              </a:rPr>
+              <a:t>Sin token: 401. Operador en ruta de administrador: 403</a:t>
+            </a:r>
+          </a:p>
+          <a:p>
+            <a:pPr algn="l">
+              <a:spcBef>
+                <a:spcPts val="600"/>
+              </a:spcBef>
+            </a:pPr>
+            <a:r>
+              <a:rPr sz="1400" b="0">
+                <a:solidFill>
+                  <a:schemeClr val="tx2"/>
+                </a:solidFill>
+                <a:latin typeface="Calibri"/>
+              </a:rPr>
+              <a:t>Autorizar con el mismo usuario: 400 (RN-07)</a:t>
+            </a:r>
+          </a:p>
+          <a:p>
+            <a:pPr algn="l">
+              <a:spcBef>
+                <a:spcPts val="600"/>
+              </a:spcBef>
+            </a:pPr>
+            <a:r>
+              <a:rPr sz="1400" b="0">
+                <a:solidFill>
+                  <a:schemeClr val="tx2"/>
+                </a:solidFill>
+                <a:latin typeface="Calibri"/>
+              </a:rPr>
+              <a:t>Pago mayor al saldo: 400 (RN-09)</a:t>
+            </a:r>
+          </a:p>
+          <a:p>
+            <a:pPr algn="l">
+              <a:spcBef>
+                <a:spcPts val="600"/>
+              </a:spcBef>
+            </a:pPr>
+            <a:r>
+              <a:rPr sz="1400" b="0">
+                <a:solidFill>
+                  <a:schemeClr val="tx2"/>
+                </a:solidFill>
+                <a:latin typeface="Calibri"/>
+              </a:rPr>
+              <a:t>Un error de negocio nunca es 500 (RNF-05)</a:t>
+            </a:r>
+          </a:p>
+        </p:txBody>
+      </p:sp>
+      <p:sp>
+        <p:nvSpPr>
+          <p:cNvPr id="33" name="Mensaje demo"/>
+          <p:cNvSpPr/>
+          <p:nvPr/>
+        </p:nvSpPr>
+        <p:spPr>
+          <a:xfrm>
+            <a:off x="457200" y="3931920"/>
+            <a:ext cx="8229600" cy="685800"/>
+          </a:xfrm>
+          <a:prstGeom prst="roundRect">
+            <a:avLst>
+              <a:gd name="adj" fmla="val 15000"/>
+            </a:avLst>
+          </a:prstGeom>
+          <a:solidFill>
+            <a:schemeClr val="accent6"/>
+          </a:solidFill>
+          <a:ln>
+            <a:noFill/>
+          </a:ln>
+        </p:spPr>
+        <p:txBody>
+          <a:bodyPr rtlCol="0" anchor="ctr"/>
+          <a:lstStyle/>
+          <a:p>
+            <a:pPr algn="ctr"/>
+          </a:p>
+        </p:txBody>
+      </p:sp>
+      <p:sp>
+        <p:nvSpPr>
+          <p:cNvPr id="34" name="Texto demo"/>
+          <p:cNvSpPr txBox="1"/>
+          <p:nvPr/>
+        </p:nvSpPr>
+        <p:spPr>
+          <a:xfrm>
+            <a:off x="731520" y="3931920"/>
+            <a:ext cx="7680960" cy="685800"/>
+          </a:xfrm>
+          <a:prstGeom prst="rect">
+            <a:avLst/>
+          </a:prstGeom>
+          <a:noFill/>
+        </p:spPr>
+        <p:txBody>
+          <a:bodyPr wrap="square" lIns="0" rIns="0" tIns="0" bIns="0" anchor="ctr">
+            <a:spAutoFit/>
+          </a:bodyPr>
+          <a:lstStyle/>
+          <a:p>
+            <a:pPr algn="l"/>
+            <a:r>
+              <a:rPr sz="1600" b="0">
+                <a:solidFill>
+                  <a:schemeClr val="tx2"/>
+                </a:solidFill>
+                <a:latin typeface="Calibri"/>
+              </a:rPr>
+              <a:t>Primero la API documentada; después la web: crear, editar, desactivar y ver cómo responden las validaciones.</a:t>
+            </a:r>
           </a:p>
         </p:txBody>
       </p:sp>
@@ -5447,6 +7773,41 @@
           </a:p>
         </p:txBody>
       </p:sp>
+      <p:sp>
+        <p:nvSpPr>
+          <p:cNvPr id="26" name="Etiqueta de sección"/>
+          <p:cNvSpPr txBox="1"/>
+          <p:nvPr/>
+        </p:nvSpPr>
+        <p:spPr>
+          <a:xfrm>
+            <a:off x="457200" y="91440"/>
+            <a:ext cx="7863840" cy="228600"/>
+          </a:xfrm>
+          <a:prstGeom prst="rect">
+            <a:avLst/>
+          </a:prstGeom>
+          <a:noFill/>
+        </p:spPr>
+        <p:txBody>
+          <a:bodyPr wrap="square" lIns="0" rIns="0" tIns="0" bIns="0" anchor="ctr">
+            <a:spAutoFit/>
+          </a:bodyPr>
+          <a:lstStyle/>
+          <a:p>
+            <a:pPr algn="l"/>
+            <a:r>
+              <a:rPr sz="1100" b="1">
+                <a:solidFill>
+                  <a:schemeClr val="accent1"/>
+                </a:solidFill>
+                <a:latin typeface="Calibri"/>
+              </a:rPr>
+              <a:t>1 · INTRODUCCIÓN: PROBLEMA Y VALOR</a:t>
+            </a:r>
+          </a:p>
+        </p:txBody>
+      </p:sp>
     </p:spTree>
   </p:cSld>
   <p:clrMapOvr>
@@ -6656,6 +9017,41 @@
           </a:p>
         </p:txBody>
       </p:sp>
+      <p:sp>
+        <p:nvSpPr>
+          <p:cNvPr id="35" name="Etiqueta de sección"/>
+          <p:cNvSpPr txBox="1"/>
+          <p:nvPr/>
+        </p:nvSpPr>
+        <p:spPr>
+          <a:xfrm>
+            <a:off x="457200" y="91440"/>
+            <a:ext cx="7863840" cy="228600"/>
+          </a:xfrm>
+          <a:prstGeom prst="rect">
+            <a:avLst/>
+          </a:prstGeom>
+          <a:noFill/>
+        </p:spPr>
+        <p:txBody>
+          <a:bodyPr wrap="square" lIns="0" rIns="0" tIns="0" bIns="0" anchor="ctr">
+            <a:spAutoFit/>
+          </a:bodyPr>
+          <a:lstStyle/>
+          <a:p>
+            <a:pPr algn="l"/>
+            <a:r>
+              <a:rPr sz="1100" b="1">
+                <a:solidFill>
+                  <a:schemeClr val="accent1"/>
+                </a:solidFill>
+                <a:latin typeface="Calibri"/>
+              </a:rPr>
+              <a:t>1 · INTRODUCCIÓN: PROBLEMA Y VALOR</a:t>
+            </a:r>
+          </a:p>
+        </p:txBody>
+      </p:sp>
     </p:spTree>
   </p:cSld>
   <p:clrMapOvr>
@@ -7263,7 +9659,7 @@
                 <a:ea typeface="Calibri" pitchFamily="34" charset="-122"/>
                 <a:cs typeface="Calibri" pitchFamily="34" charset="-120"/>
               </a:rPr>
-              <a:t>Cada punto tiene un código y una prueba que lo comprueba. No programamos a partir de pedidos sueltos: primero se escribió qué debía hacer el sistema.</a:t>
+              <a:t>Cada requisito (RF), regla (RN) y condición de calidad (RNF) tiene un código y una prueba que lo comprueba. Primero se escribió qué debía hacer el sistema; después se construyó.</a:t>
             </a:r>
             <a:endParaRPr lang="en-US" sz="1600" dirty="0"/>
           </a:p>
@@ -7311,6 +9707,41 @@
               <a:t>4</a:t>
             </a:fld>
             <a:endParaRPr lang="en-US"/>
+          </a:p>
+        </p:txBody>
+      </p:sp>
+      <p:sp>
+        <p:nvSpPr>
+          <p:cNvPr id="26" name="Etiqueta de sección"/>
+          <p:cNvSpPr txBox="1"/>
+          <p:nvPr/>
+        </p:nvSpPr>
+        <p:spPr>
+          <a:xfrm>
+            <a:off x="457200" y="91440"/>
+            <a:ext cx="7863840" cy="228600"/>
+          </a:xfrm>
+          <a:prstGeom prst="rect">
+            <a:avLst/>
+          </a:prstGeom>
+          <a:noFill/>
+        </p:spPr>
+        <p:txBody>
+          <a:bodyPr wrap="square" lIns="0" rIns="0" tIns="0" bIns="0" anchor="ctr">
+            <a:spAutoFit/>
+          </a:bodyPr>
+          <a:lstStyle/>
+          <a:p>
+            <a:pPr algn="l"/>
+            <a:r>
+              <a:rPr sz="1100" b="1">
+                <a:solidFill>
+                  <a:schemeClr val="accent1"/>
+                </a:solidFill>
+                <a:latin typeface="Calibri"/>
+              </a:rPr>
+              <a:t>2 · ESPECIFICACIONES Y TRAZABILIDAD</a:t>
+            </a:r>
           </a:p>
         </p:txBody>
       </p:sp>
@@ -7376,7 +9807,7 @@
                 <a:ea typeface="Cambria" pitchFamily="34" charset="-122"/>
                 <a:cs typeface="Cambria" pitchFamily="34" charset="-120"/>
               </a:rPr>
-              <a:t>Arquitectura en capas</a:t>
+              <a:t>Arquitectura en N capas</a:t>
             </a:r>
             <a:endParaRPr lang="en-US" sz="3000" dirty="0"/>
           </a:p>
@@ -7384,465 +9815,164 @@
       </p:sp>
       <p:sp>
         <p:nvSpPr>
-          <p:cNvPr id="3" name="Capa Pantallas web"/>
+          <p:cNvPr id="25" name="Slide Number Placeholder 0"/>
+          <p:cNvSpPr>
+            <a:spLocks noGrp="1"/>
+          </p:cNvSpPr>
+          <p:nvPr>
+            <p:ph type="sldNum" sz="quarter" idx="4294967295"/>
+          </p:nvPr>
+        </p:nvSpPr>
+        <p:spPr>
+          <a:xfrm>
+            <a:off x="8229600" y="4754880"/>
+            <a:ext cx="457200" cy="228600"/>
+          </a:xfrm>
+          <a:prstGeom prst="rect">
+            <a:avLst/>
+          </a:prstGeom>
+          <a:extLst>
+            <a:ext uri="{C572A759-6A51-4108-AA02-DFA0A04FC94B}">
+              <ma14:wrappingTextBoxFlag xmlns:ma14="http://schemas.microsoft.com/office/mac/drawingml/2011/main" xmlns="" val="0"/>
+            </a:ext>
+          </a:extLst>
+        </p:spPr>
+        <p:txBody>
+          <a:bodyPr/>
+          <a:lstStyle>
+            <a:lvl1pPr>
+              <a:defRPr sz="1000">
+                <a:solidFill>
+                  <a:schemeClr val="tx2"/>
+                </a:solidFill>
+              </a:defRPr>
+            </a:lvl1pPr>
+          </a:lstStyle>
+          <a:p>
+            <a:pPr algn="r"/>
+            <a:fld id="{F7021451-1387-4CA6-816F-3879F97B5CBC}" type="slidenum">
+              <a:rPr lang="en-US" b="0"/>
+              <a:t>7</a:t>
+            </a:fld>
+            <a:endParaRPr lang="en-US"/>
+          </a:p>
+        </p:txBody>
+      </p:sp>
+      <p:sp>
+        <p:nvSpPr>
+          <p:cNvPr id="26" name="Etiqueta de sección"/>
+          <p:cNvSpPr txBox="1"/>
+          <p:nvPr/>
+        </p:nvSpPr>
+        <p:spPr>
+          <a:xfrm>
+            <a:off x="457200" y="91440"/>
+            <a:ext cx="7863840" cy="228600"/>
+          </a:xfrm>
+          <a:prstGeom prst="rect">
+            <a:avLst/>
+          </a:prstGeom>
+          <a:noFill/>
+        </p:spPr>
+        <p:txBody>
+          <a:bodyPr wrap="square" lIns="0" rIns="0" tIns="0" bIns="0" anchor="ctr">
+            <a:spAutoFit/>
+          </a:bodyPr>
+          <a:lstStyle/>
+          <a:p>
+            <a:pPr algn="l"/>
+            <a:r>
+              <a:rPr sz="1100" b="1">
+                <a:solidFill>
+                  <a:schemeClr val="accent1"/>
+                </a:solidFill>
+                <a:latin typeface="Calibri"/>
+              </a:rPr>
+              <a:t>3 · ARQUITECTURA Y DECISIONES TÉCNICAS</a:t>
+            </a:r>
+          </a:p>
+        </p:txBody>
+      </p:sp>
+      <p:sp>
+        <p:nvSpPr>
+          <p:cNvPr id="27" name="Capa API"/>
           <p:cNvSpPr/>
           <p:nvPr/>
         </p:nvSpPr>
         <p:spPr>
           <a:xfrm>
-            <a:off x="457200" y="1188720"/>
-            <a:ext cx="3657600" cy="548640"/>
+            <a:off x="457200" y="1143000"/>
+            <a:ext cx="2468880" cy="640080"/>
           </a:xfrm>
           <a:prstGeom prst="roundRect">
             <a:avLst>
-              <a:gd name="adj" fmla="val 13333"/>
-            </a:avLst>
-          </a:prstGeom>
-          <a:solidFill>
-            <a:schemeClr val="accent6"/>
-          </a:solidFill>
-          <a:ln/>
-        </p:spPr>
-        <p:txBody>
-          <a:bodyPr/>
-          <a:lstStyle/>
-          <a:p>
-            <a:endParaRPr lang="es-PE"/>
-          </a:p>
-        </p:txBody>
-      </p:sp>
-      <p:sp>
-        <p:nvSpPr>
-          <p:cNvPr id="4" name="Texto capa Pantallas web"/>
-          <p:cNvSpPr txBox="1"/>
-          <p:nvPr/>
-        </p:nvSpPr>
-        <p:spPr>
-          <a:xfrm>
-            <a:off x="640080" y="1188720"/>
-            <a:ext cx="3291840" cy="548640"/>
-          </a:xfrm>
-          <a:prstGeom prst="rect">
-            <a:avLst/>
-          </a:prstGeom>
-          <a:noFill/>
-          <a:ln/>
-        </p:spPr>
-        <p:txBody>
-          <a:bodyPr wrap="square" lIns="0" tIns="0" rIns="0" bIns="0" rtlCol="0" anchor="ctr"/>
-          <a:lstStyle/>
-          <a:p>
-            <a:pPr marL="0" indent="0">
-              <a:buNone/>
-            </a:pPr>
-            <a:r>
-              <a:rPr lang="en-US" sz="1400" b="1" dirty="0">
-                <a:solidFill>
-                  <a:schemeClr val="tx2"/>
-                </a:solidFill>
-                <a:latin typeface="Calibri" pitchFamily="34" charset="0"/>
-                <a:ea typeface="Calibri" pitchFamily="34" charset="-122"/>
-                <a:cs typeface="Calibri" pitchFamily="34" charset="-120"/>
-              </a:rPr>
-              <a:t>Frontend</a:t>
-            </a:r>
-            <a:endParaRPr lang="en-US" sz="1400" dirty="0"/>
-          </a:p>
-          <a:p>
-            <a:pPr marL="0" indent="0">
-              <a:buNone/>
-            </a:pPr>
-            <a:r>
-              <a:rPr lang="en-US" sz="1200" dirty="0">
-                <a:solidFill>
-                  <a:schemeClr val="tx2"/>
-                </a:solidFill>
-                <a:latin typeface="Calibri" pitchFamily="34" charset="0"/>
-                <a:ea typeface="Calibri" pitchFamily="34" charset="-122"/>
-                <a:cs typeface="Calibri" pitchFamily="34" charset="-120"/>
-              </a:rPr>
-              <a:t>Angular 21</a:t>
-            </a:r>
-            <a:endParaRPr lang="en-US" sz="1400" dirty="0"/>
-          </a:p>
-        </p:txBody>
-      </p:sp>
-      <p:sp>
-        <p:nvSpPr>
-          <p:cNvPr id="5" name="Capa Puerta de entrada"/>
-          <p:cNvSpPr/>
-          <p:nvPr/>
-        </p:nvSpPr>
-        <p:spPr>
-          <a:xfrm>
-            <a:off x="457200" y="1865376"/>
-            <a:ext cx="3657600" cy="548640"/>
-          </a:xfrm>
-          <a:prstGeom prst="roundRect">
-            <a:avLst>
-              <a:gd name="adj" fmla="val 13333"/>
-            </a:avLst>
-          </a:prstGeom>
-          <a:solidFill>
-            <a:schemeClr val="accent5"/>
-          </a:solidFill>
-          <a:ln/>
-        </p:spPr>
-        <p:txBody>
-          <a:bodyPr/>
-          <a:lstStyle/>
-          <a:p>
-            <a:endParaRPr lang="es-PE"/>
-          </a:p>
-        </p:txBody>
-      </p:sp>
-      <p:sp>
-        <p:nvSpPr>
-          <p:cNvPr id="6" name="Texto capa Puerta de entrada"/>
-          <p:cNvSpPr txBox="1"/>
-          <p:nvPr/>
-        </p:nvSpPr>
-        <p:spPr>
-          <a:xfrm>
-            <a:off x="640080" y="1865376"/>
-            <a:ext cx="3291840" cy="548640"/>
-          </a:xfrm>
-          <a:prstGeom prst="rect">
-            <a:avLst/>
-          </a:prstGeom>
-          <a:noFill/>
-          <a:ln/>
-        </p:spPr>
-        <p:txBody>
-          <a:bodyPr wrap="square" lIns="0" tIns="0" rIns="0" bIns="0" rtlCol="0" anchor="ctr"/>
-          <a:lstStyle/>
-          <a:p>
-            <a:pPr marL="0" indent="0">
-              <a:buNone/>
-            </a:pPr>
-            <a:r>
-              <a:rPr lang="en-US" sz="1400" b="1" dirty="0">
-                <a:solidFill>
-                  <a:schemeClr val="tx2"/>
-                </a:solidFill>
-                <a:latin typeface="Calibri" pitchFamily="34" charset="0"/>
-                <a:ea typeface="Calibri" pitchFamily="34" charset="-122"/>
-                <a:cs typeface="Calibri" pitchFamily="34" charset="-120"/>
-              </a:rPr>
-              <a:t>Backend</a:t>
-            </a:r>
-            <a:endParaRPr lang="en-US" sz="1400" dirty="0"/>
-          </a:p>
-          <a:p>
-            <a:pPr marL="0" indent="0">
-              <a:buNone/>
-            </a:pPr>
-            <a:r>
-              <a:rPr lang="en-US" sz="1200" dirty="0">
-                <a:solidFill>
-                  <a:schemeClr val="tx2"/>
-                </a:solidFill>
-                <a:latin typeface="Calibri" pitchFamily="34" charset="0"/>
-                <a:ea typeface="Calibri" pitchFamily="34" charset="-122"/>
-                <a:cs typeface="Calibri" pitchFamily="34" charset="-120"/>
-              </a:rPr>
-              <a:t>API (Controller’s) </a:t>
-            </a:r>
-            <a:r>
-              <a:rPr lang="en-US" sz="1200" dirty="0" err="1">
-                <a:solidFill>
-                  <a:schemeClr val="tx2"/>
-                </a:solidFill>
-                <a:latin typeface="Calibri" pitchFamily="34" charset="0"/>
-                <a:ea typeface="Calibri" pitchFamily="34" charset="-122"/>
-                <a:cs typeface="Calibri" pitchFamily="34" charset="-120"/>
-              </a:rPr>
-              <a:t>en</a:t>
-            </a:r>
-            <a:r>
-              <a:rPr lang="en-US" sz="1200" dirty="0">
-                <a:solidFill>
-                  <a:schemeClr val="tx2"/>
-                </a:solidFill>
-                <a:latin typeface="Calibri" pitchFamily="34" charset="0"/>
-                <a:ea typeface="Calibri" pitchFamily="34" charset="-122"/>
-                <a:cs typeface="Calibri" pitchFamily="34" charset="-120"/>
-              </a:rPr>
-              <a:t> .NET 10</a:t>
-            </a:r>
-            <a:endParaRPr lang="en-US" sz="1400" dirty="0"/>
-          </a:p>
-        </p:txBody>
-      </p:sp>
-      <p:sp>
-        <p:nvSpPr>
-          <p:cNvPr id="7" name="Capa Reglas del negocio"/>
-          <p:cNvSpPr/>
-          <p:nvPr/>
-        </p:nvSpPr>
-        <p:spPr>
-          <a:xfrm>
-            <a:off x="457200" y="2542032"/>
-            <a:ext cx="3657600" cy="548640"/>
-          </a:xfrm>
-          <a:prstGeom prst="roundRect">
-            <a:avLst>
-              <a:gd name="adj" fmla="val 13333"/>
-            </a:avLst>
-          </a:prstGeom>
-          <a:solidFill>
-            <a:schemeClr val="accent2"/>
-          </a:solidFill>
-          <a:ln/>
-        </p:spPr>
-        <p:txBody>
-          <a:bodyPr/>
-          <a:lstStyle/>
-          <a:p>
-            <a:endParaRPr lang="es-PE"/>
-          </a:p>
-        </p:txBody>
-      </p:sp>
-      <p:sp>
-        <p:nvSpPr>
-          <p:cNvPr id="8" name="Texto capa Reglas del negocio"/>
-          <p:cNvSpPr txBox="1"/>
-          <p:nvPr/>
-        </p:nvSpPr>
-        <p:spPr>
-          <a:xfrm>
-            <a:off x="640080" y="2542032"/>
-            <a:ext cx="3291840" cy="548640"/>
-          </a:xfrm>
-          <a:prstGeom prst="rect">
-            <a:avLst/>
-          </a:prstGeom>
-          <a:noFill/>
-          <a:ln/>
-        </p:spPr>
-        <p:txBody>
-          <a:bodyPr wrap="square" lIns="0" tIns="0" rIns="0" bIns="0" rtlCol="0" anchor="ctr"/>
-          <a:lstStyle/>
-          <a:p>
-            <a:pPr marL="0" indent="0">
-              <a:buNone/>
-            </a:pPr>
-            <a:r>
-              <a:rPr lang="en-US" sz="1400" b="1" dirty="0">
-                <a:solidFill>
-                  <a:schemeClr val="bg1"/>
-                </a:solidFill>
-                <a:latin typeface="Calibri" pitchFamily="34" charset="0"/>
-                <a:ea typeface="Calibri" pitchFamily="34" charset="-122"/>
-                <a:cs typeface="Calibri" pitchFamily="34" charset="-120"/>
-              </a:rPr>
-              <a:t>Reglas del negocio</a:t>
-            </a:r>
-            <a:endParaRPr lang="en-US" sz="1400" dirty="0"/>
-          </a:p>
-          <a:p>
-            <a:pPr marL="0" indent="0">
-              <a:buNone/>
-            </a:pPr>
-            <a:r>
-              <a:rPr lang="en-US" sz="1200" dirty="0">
-                <a:solidFill>
-                  <a:schemeClr val="bg1"/>
-                </a:solidFill>
-                <a:latin typeface="Calibri" pitchFamily="34" charset="0"/>
-                <a:ea typeface="Calibri" pitchFamily="34" charset="-122"/>
-                <a:cs typeface="Calibri" pitchFamily="34" charset="-120"/>
-              </a:rPr>
-              <a:t>lo que se puede y no se puede hacer</a:t>
-            </a:r>
-            <a:endParaRPr lang="en-US" sz="1400" dirty="0"/>
-          </a:p>
-        </p:txBody>
-      </p:sp>
-      <p:sp>
-        <p:nvSpPr>
-          <p:cNvPr id="9" name="Capa Acceso a datos"/>
-          <p:cNvSpPr/>
-          <p:nvPr/>
-        </p:nvSpPr>
-        <p:spPr>
-          <a:xfrm>
-            <a:off x="457200" y="3218688"/>
-            <a:ext cx="3657600" cy="548640"/>
-          </a:xfrm>
-          <a:prstGeom prst="roundRect">
-            <a:avLst>
-              <a:gd name="adj" fmla="val 13333"/>
+              <a:gd name="adj" fmla="val 5000"/>
             </a:avLst>
           </a:prstGeom>
           <a:solidFill>
             <a:schemeClr val="accent1"/>
           </a:solidFill>
-          <a:ln/>
-        </p:spPr>
-        <p:txBody>
-          <a:bodyPr/>
-          <a:lstStyle/>
-          <a:p>
-            <a:endParaRPr lang="es-PE"/>
-          </a:p>
-        </p:txBody>
-      </p:sp>
-      <p:sp>
-        <p:nvSpPr>
-          <p:cNvPr id="10" name="Texto capa Acceso a datos"/>
-          <p:cNvSpPr txBox="1"/>
-          <p:nvPr/>
-        </p:nvSpPr>
-        <p:spPr>
-          <a:xfrm>
-            <a:off x="640080" y="3218688"/>
-            <a:ext cx="3291840" cy="548640"/>
-          </a:xfrm>
-          <a:prstGeom prst="rect">
-            <a:avLst/>
-          </a:prstGeom>
-          <a:noFill/>
-          <a:ln/>
-        </p:spPr>
-        <p:txBody>
-          <a:bodyPr wrap="square" lIns="0" tIns="0" rIns="0" bIns="0" rtlCol="0" anchor="ctr"/>
-          <a:lstStyle/>
-          <a:p>
-            <a:pPr marL="0" indent="0">
-              <a:buNone/>
-            </a:pPr>
-            <a:r>
-              <a:rPr lang="en-US" sz="1400" b="1" dirty="0">
-                <a:solidFill>
-                  <a:schemeClr val="bg1"/>
-                </a:solidFill>
-                <a:latin typeface="Calibri" pitchFamily="34" charset="0"/>
-                <a:ea typeface="Calibri" pitchFamily="34" charset="-122"/>
-                <a:cs typeface="Calibri" pitchFamily="34" charset="-120"/>
-              </a:rPr>
-              <a:t>Acceso a datos</a:t>
-            </a:r>
-            <a:endParaRPr lang="en-US" sz="1400" dirty="0"/>
-          </a:p>
-          <a:p>
-            <a:pPr marL="0" indent="0">
-              <a:buNone/>
-            </a:pPr>
-            <a:r>
-              <a:rPr lang="en-US" sz="1200" dirty="0">
-                <a:solidFill>
-                  <a:schemeClr val="bg1"/>
-                </a:solidFill>
-                <a:latin typeface="Calibri" pitchFamily="34" charset="0"/>
-                <a:ea typeface="Calibri" pitchFamily="34" charset="-122"/>
-                <a:cs typeface="Calibri" pitchFamily="34" charset="-120"/>
-              </a:rPr>
-              <a:t>Entity Framework</a:t>
-            </a:r>
-            <a:endParaRPr lang="en-US" sz="1400" dirty="0"/>
-          </a:p>
-        </p:txBody>
-      </p:sp>
-      <p:sp>
-        <p:nvSpPr>
-          <p:cNvPr id="11" name="Capa Base de datos"/>
+          <a:ln>
+            <a:noFill/>
+          </a:ln>
+        </p:spPr>
+        <p:txBody>
+          <a:bodyPr rtlCol="0" anchor="ctr"/>
+          <a:lstStyle/>
+          <a:p>
+            <a:pPr algn="ctr"/>
+          </a:p>
+        </p:txBody>
+      </p:sp>
+      <p:sp>
+        <p:nvSpPr>
+          <p:cNvPr id="28" name="Nombre capa API"/>
+          <p:cNvSpPr txBox="1"/>
+          <p:nvPr/>
+        </p:nvSpPr>
+        <p:spPr>
+          <a:xfrm>
+            <a:off x="594360" y="1143000"/>
+            <a:ext cx="2194560" cy="640080"/>
+          </a:xfrm>
+          <a:prstGeom prst="rect">
+            <a:avLst/>
+          </a:prstGeom>
+          <a:noFill/>
+        </p:spPr>
+        <p:txBody>
+          <a:bodyPr wrap="square" lIns="0" rIns="0" tIns="0" bIns="0" anchor="ctr">
+            <a:spAutoFit/>
+          </a:bodyPr>
+          <a:lstStyle/>
+          <a:p>
+            <a:pPr algn="l"/>
+            <a:r>
+              <a:rPr sz="1800" b="1">
+                <a:solidFill>
+                  <a:srgbClr val="FFFFFF"/>
+                </a:solidFill>
+                <a:latin typeface="Cambria"/>
+              </a:rPr>
+              <a:t>API</a:t>
+            </a:r>
+          </a:p>
+        </p:txBody>
+      </p:sp>
+      <p:sp>
+        <p:nvSpPr>
+          <p:cNvPr id="29" name="Proyecto API"/>
           <p:cNvSpPr/>
           <p:nvPr/>
         </p:nvSpPr>
         <p:spPr>
           <a:xfrm>
-            <a:off x="457200" y="3895344"/>
-            <a:ext cx="3657600" cy="548640"/>
+            <a:off x="3063240" y="1143000"/>
+            <a:ext cx="5623560" cy="640080"/>
           </a:xfrm>
           <a:prstGeom prst="roundRect">
             <a:avLst>
-              <a:gd name="adj" fmla="val 13333"/>
-            </a:avLst>
-          </a:prstGeom>
-          <a:solidFill>
-            <a:schemeClr val="tx2"/>
-          </a:solidFill>
-          <a:ln/>
-        </p:spPr>
-        <p:txBody>
-          <a:bodyPr/>
-          <a:lstStyle/>
-          <a:p>
-            <a:endParaRPr lang="es-PE"/>
-          </a:p>
-        </p:txBody>
-      </p:sp>
-      <p:sp>
-        <p:nvSpPr>
-          <p:cNvPr id="12" name="Texto capa Base de datos"/>
-          <p:cNvSpPr txBox="1"/>
-          <p:nvPr/>
-        </p:nvSpPr>
-        <p:spPr>
-          <a:xfrm>
-            <a:off x="640080" y="3895344"/>
-            <a:ext cx="3291840" cy="548640"/>
-          </a:xfrm>
-          <a:prstGeom prst="rect">
-            <a:avLst/>
-          </a:prstGeom>
-          <a:noFill/>
-          <a:ln/>
-        </p:spPr>
-        <p:txBody>
-          <a:bodyPr wrap="square" lIns="0" tIns="0" rIns="0" bIns="0" rtlCol="0" anchor="ctr"/>
-          <a:lstStyle/>
-          <a:p>
-            <a:pPr marL="0" indent="0">
-              <a:buNone/>
-            </a:pPr>
-            <a:r>
-              <a:rPr lang="en-US" sz="1400" b="1" dirty="0">
-                <a:solidFill>
-                  <a:schemeClr val="bg1"/>
-                </a:solidFill>
-                <a:latin typeface="Calibri" pitchFamily="34" charset="0"/>
-                <a:ea typeface="Calibri" pitchFamily="34" charset="-122"/>
-                <a:cs typeface="Calibri" pitchFamily="34" charset="-120"/>
-              </a:rPr>
-              <a:t>Base de datos</a:t>
-            </a:r>
-            <a:endParaRPr lang="en-US" sz="1400" dirty="0"/>
-          </a:p>
-          <a:p>
-            <a:pPr marL="0" indent="0">
-              <a:buNone/>
-            </a:pPr>
-            <a:r>
-              <a:rPr lang="en-US" sz="1200" dirty="0">
-                <a:solidFill>
-                  <a:schemeClr val="bg1"/>
-                </a:solidFill>
-                <a:latin typeface="Calibri" pitchFamily="34" charset="0"/>
-                <a:ea typeface="Calibri" pitchFamily="34" charset="-122"/>
-                <a:cs typeface="Calibri" pitchFamily="34" charset="-120"/>
-              </a:rPr>
-              <a:t>SQL Server</a:t>
-            </a:r>
-            <a:endParaRPr lang="en-US" sz="1400" dirty="0"/>
-          </a:p>
-        </p:txBody>
-      </p:sp>
-      <p:sp>
-        <p:nvSpPr>
-          <p:cNvPr id="13" name="Bloque ¿Por qué la elegimos?"/>
-          <p:cNvSpPr/>
-          <p:nvPr/>
-        </p:nvSpPr>
-        <p:spPr>
-          <a:xfrm>
-            <a:off x="4389120" y="1188720"/>
-            <a:ext cx="4297680" cy="1609344"/>
-          </a:xfrm>
-          <a:prstGeom prst="roundRect">
-            <a:avLst>
-              <a:gd name="adj" fmla="val 5682"/>
+              <a:gd name="adj" fmla="val 5000"/>
             </a:avLst>
           </a:prstGeom>
           <a:solidFill>
@@ -7852,206 +9982,143 @@
             <a:solidFill>
               <a:srgbClr val="DCE4EA"/>
             </a:solidFill>
-            <a:prstDash val="solid"/>
           </a:ln>
         </p:spPr>
         <p:txBody>
-          <a:bodyPr/>
-          <a:lstStyle/>
-          <a:p>
-            <a:endParaRPr lang="es-PE"/>
-          </a:p>
-        </p:txBody>
-      </p:sp>
-      <p:sp>
-        <p:nvSpPr>
-          <p:cNvPr id="14" name="Icono ¿Por qué la elegimos? (círculo)"/>
+          <a:bodyPr rtlCol="0" anchor="ctr"/>
+          <a:lstStyle/>
+          <a:p>
+            <a:pPr algn="ctr"/>
+          </a:p>
+        </p:txBody>
+      </p:sp>
+      <p:sp>
+        <p:nvSpPr>
+          <p:cNvPr id="30" name="Texto proyecto API"/>
+          <p:cNvSpPr txBox="1"/>
+          <p:nvPr/>
+        </p:nvSpPr>
+        <p:spPr>
+          <a:xfrm>
+            <a:off x="3246120" y="1188720"/>
+            <a:ext cx="5303520" cy="548640"/>
+          </a:xfrm>
+          <a:prstGeom prst="rect">
+            <a:avLst/>
+          </a:prstGeom>
+          <a:noFill/>
+        </p:spPr>
+        <p:txBody>
+          <a:bodyPr wrap="square" lIns="0" rIns="0" tIns="0" bIns="0" anchor="ctr">
+            <a:spAutoFit/>
+          </a:bodyPr>
+          <a:lstStyle/>
+          <a:p>
+            <a:pPr algn="l"/>
+            <a:r>
+              <a:rPr sz="1400" b="1">
+                <a:solidFill>
+                  <a:schemeClr val="tx2"/>
+                </a:solidFill>
+                <a:latin typeface="Calibri"/>
+              </a:rPr>
+              <a:t>GestionContratos.API</a:t>
+            </a:r>
+          </a:p>
+          <a:p>
+            <a:pPr algn="l"/>
+            <a:r>
+              <a:rPr sz="1400" b="0">
+                <a:solidFill>
+                  <a:schemeClr val="tx2"/>
+                </a:solidFill>
+                <a:latin typeface="Calibri"/>
+              </a:rPr>
+              <a:t>Controllers, JWT, OpenAPI. No tiene lógica de negocio</a:t>
+            </a:r>
+          </a:p>
+        </p:txBody>
+      </p:sp>
+      <p:sp>
+        <p:nvSpPr>
+          <p:cNvPr id="31" name="Capa Negocio"/>
           <p:cNvSpPr/>
           <p:nvPr/>
         </p:nvSpPr>
         <p:spPr>
           <a:xfrm>
-            <a:off x="4572000" y="1298448"/>
-            <a:ext cx="411480" cy="411480"/>
-          </a:xfrm>
-          <a:prstGeom prst="ellipse">
-            <a:avLst/>
-          </a:prstGeom>
-          <a:solidFill>
-            <a:srgbClr val="2F6F8F"/>
-          </a:solidFill>
-          <a:ln/>
-        </p:spPr>
-        <p:txBody>
-          <a:bodyPr/>
-          <a:lstStyle/>
-          <a:p>
-            <a:endParaRPr lang="es-PE"/>
-          </a:p>
-        </p:txBody>
-      </p:sp>
-      <p:pic>
-        <p:nvPicPr>
-          <p:cNvPr id="15" name="Icono ¿Por qué la elegimos?" descr="Icono ¿Por qué la elegimos?"/>
-          <p:cNvPicPr>
-            <a:picLocks noChangeAspect="1"/>
-          </p:cNvPicPr>
-          <p:nvPr/>
-        </p:nvPicPr>
-        <p:blipFill>
-          <a:blip r:embed="rId3"/>
-          <a:stretch>
-            <a:fillRect/>
-          </a:stretch>
-        </p:blipFill>
-        <p:spPr>
-          <a:xfrm>
-            <a:off x="4674870" y="1401318"/>
-            <a:ext cx="205740" cy="205740"/>
-          </a:xfrm>
-          <a:prstGeom prst="rect">
-            <a:avLst/>
-          </a:prstGeom>
-        </p:spPr>
-      </p:pic>
-      <p:sp>
-        <p:nvSpPr>
-          <p:cNvPr id="16" name="Título ¿Por qué la elegimos?"/>
-          <p:cNvSpPr txBox="1"/>
-          <p:nvPr/>
-        </p:nvSpPr>
-        <p:spPr>
-          <a:xfrm>
-            <a:off x="5120640" y="1298448"/>
-            <a:ext cx="3383280" cy="411480"/>
-          </a:xfrm>
-          <a:prstGeom prst="rect">
-            <a:avLst/>
-          </a:prstGeom>
-          <a:noFill/>
-          <a:ln/>
-        </p:spPr>
-        <p:txBody>
-          <a:bodyPr wrap="square" lIns="0" tIns="0" rIns="0" bIns="0" rtlCol="0" anchor="ctr"/>
-          <a:lstStyle/>
-          <a:p>
-            <a:pPr marL="0" indent="0">
-              <a:buNone/>
-            </a:pPr>
-            <a:r>
-              <a:rPr lang="en-US" sz="1600" b="1" dirty="0">
-                <a:solidFill>
-                  <a:schemeClr val="tx2"/>
-                </a:solidFill>
-                <a:latin typeface="Calibri" pitchFamily="34" charset="0"/>
-                <a:ea typeface="Calibri" pitchFamily="34" charset="-122"/>
-                <a:cs typeface="Calibri" pitchFamily="34" charset="-120"/>
-              </a:rPr>
-              <a:t>¿Por qué la elegimos?</a:t>
-            </a:r>
-            <a:endParaRPr lang="en-US" sz="1600" dirty="0"/>
-          </a:p>
-        </p:txBody>
-      </p:sp>
-      <p:sp>
-        <p:nvSpPr>
-          <p:cNvPr id="17" name="Lista ¿Por qué la elegimos?"/>
-          <p:cNvSpPr txBox="1"/>
-          <p:nvPr/>
-        </p:nvSpPr>
-        <p:spPr>
-          <a:xfrm>
-            <a:off x="4572000" y="1783080"/>
-            <a:ext cx="3931920" cy="960120"/>
-          </a:xfrm>
-          <a:prstGeom prst="rect">
-            <a:avLst/>
-          </a:prstGeom>
-          <a:noFill/>
-          <a:ln/>
-        </p:spPr>
-        <p:txBody>
-          <a:bodyPr wrap="square" lIns="0" tIns="0" rIns="0" bIns="0" rtlCol="0" anchor="t"/>
-          <a:lstStyle/>
-          <a:p>
-            <a:pPr marL="342900" indent="-342900">
-              <a:spcAft>
-                <a:spcPts val="200"/>
-              </a:spcAft>
-              <a:buSzPct val="100000"/>
-              <a:buChar char="•"/>
-            </a:pPr>
-            <a:r>
-              <a:rPr lang="en-US" sz="1400" dirty="0">
-                <a:solidFill>
-                  <a:schemeClr val="tx1"/>
-                </a:solidFill>
-                <a:latin typeface="Calibri" pitchFamily="34" charset="0"/>
-                <a:ea typeface="Calibri" pitchFamily="34" charset="-122"/>
-                <a:cs typeface="Calibri" pitchFamily="34" charset="-120"/>
-              </a:rPr>
-              <a:t>Cada parte tiene una sola tarea</a:t>
-            </a:r>
-            <a:endParaRPr lang="en-US" sz="1400" dirty="0"/>
-          </a:p>
-          <a:p>
-            <a:pPr marL="342900" indent="-342900">
-              <a:spcAft>
-                <a:spcPts val="200"/>
-              </a:spcAft>
-              <a:buSzPct val="100000"/>
-              <a:buChar char="•"/>
-            </a:pPr>
-            <a:r>
-              <a:rPr lang="en-US" sz="1400" dirty="0">
-                <a:solidFill>
-                  <a:schemeClr val="tx1"/>
-                </a:solidFill>
-                <a:latin typeface="Calibri" pitchFamily="34" charset="0"/>
-                <a:ea typeface="Calibri" pitchFamily="34" charset="-122"/>
-                <a:cs typeface="Calibri" pitchFamily="34" charset="-120"/>
-              </a:rPr>
-              <a:t>Evita mezclar pantallas, reglas y datos</a:t>
-            </a:r>
-            <a:endParaRPr lang="en-US" sz="1400" dirty="0"/>
-          </a:p>
-          <a:p>
-            <a:pPr marL="342900" indent="-342900">
-              <a:spcAft>
-                <a:spcPts val="200"/>
-              </a:spcAft>
-              <a:buSzPct val="100000"/>
-              <a:buChar char="•"/>
-            </a:pPr>
-            <a:r>
-              <a:rPr lang="en-US" sz="1400" dirty="0">
-                <a:solidFill>
-                  <a:schemeClr val="tx1"/>
-                </a:solidFill>
-                <a:latin typeface="Calibri" pitchFamily="34" charset="0"/>
-                <a:ea typeface="Calibri" pitchFamily="34" charset="-122"/>
-                <a:cs typeface="Calibri" pitchFamily="34" charset="-120"/>
-              </a:rPr>
-              <a:t>La API nunca toca la base de datos directo</a:t>
-            </a:r>
-            <a:endParaRPr lang="en-US" sz="1400" dirty="0"/>
-          </a:p>
-        </p:txBody>
-      </p:sp>
-      <p:sp>
-        <p:nvSpPr>
-          <p:cNvPr id="18" name="Bloque ¿Qué ganamos?"/>
-          <p:cNvSpPr/>
-          <p:nvPr/>
-        </p:nvSpPr>
-        <p:spPr>
-          <a:xfrm>
-            <a:off x="4389120" y="2926080"/>
-            <a:ext cx="4297680" cy="1609344"/>
+            <a:off x="457200" y="1874519"/>
+            <a:ext cx="2468880" cy="640080"/>
           </a:xfrm>
           <a:prstGeom prst="roundRect">
             <a:avLst>
-              <a:gd name="adj" fmla="val 5682"/>
+              <a:gd name="adj" fmla="val 5000"/>
+            </a:avLst>
+          </a:prstGeom>
+          <a:solidFill>
+            <a:schemeClr val="accent1"/>
+          </a:solidFill>
+          <a:ln>
+            <a:noFill/>
+          </a:ln>
+        </p:spPr>
+        <p:txBody>
+          <a:bodyPr rtlCol="0" anchor="ctr"/>
+          <a:lstStyle/>
+          <a:p>
+            <a:pPr algn="ctr"/>
+          </a:p>
+        </p:txBody>
+      </p:sp>
+      <p:sp>
+        <p:nvSpPr>
+          <p:cNvPr id="32" name="Nombre capa Negocio"/>
+          <p:cNvSpPr txBox="1"/>
+          <p:nvPr/>
+        </p:nvSpPr>
+        <p:spPr>
+          <a:xfrm>
+            <a:off x="594360" y="1874519"/>
+            <a:ext cx="2194560" cy="640080"/>
+          </a:xfrm>
+          <a:prstGeom prst="rect">
+            <a:avLst/>
+          </a:prstGeom>
+          <a:noFill/>
+        </p:spPr>
+        <p:txBody>
+          <a:bodyPr wrap="square" lIns="0" rIns="0" tIns="0" bIns="0" anchor="ctr">
+            <a:spAutoFit/>
+          </a:bodyPr>
+          <a:lstStyle/>
+          <a:p>
+            <a:pPr algn="l"/>
+            <a:r>
+              <a:rPr sz="1800" b="1">
+                <a:solidFill>
+                  <a:srgbClr val="FFFFFF"/>
+                </a:solidFill>
+                <a:latin typeface="Cambria"/>
+              </a:rPr>
+              <a:t>Negocio</a:t>
+            </a:r>
+          </a:p>
+        </p:txBody>
+      </p:sp>
+      <p:sp>
+        <p:nvSpPr>
+          <p:cNvPr id="33" name="Proyecto Negocio"/>
+          <p:cNvSpPr/>
+          <p:nvPr/>
+        </p:nvSpPr>
+        <p:spPr>
+          <a:xfrm>
+            <a:off x="3063240" y="1874519"/>
+            <a:ext cx="5623560" cy="640080"/>
+          </a:xfrm>
+          <a:prstGeom prst="roundRect">
+            <a:avLst>
+              <a:gd name="adj" fmla="val 5000"/>
             </a:avLst>
           </a:prstGeom>
           <a:solidFill>
@@ -8061,234 +10128,430 @@
             <a:solidFill>
               <a:srgbClr val="DCE4EA"/>
             </a:solidFill>
-            <a:prstDash val="solid"/>
           </a:ln>
         </p:spPr>
         <p:txBody>
-          <a:bodyPr/>
-          <a:lstStyle/>
-          <a:p>
-            <a:endParaRPr lang="es-PE"/>
-          </a:p>
-        </p:txBody>
-      </p:sp>
-      <p:sp>
-        <p:nvSpPr>
-          <p:cNvPr id="19" name="Icono ¿Qué ganamos? (círculo)"/>
+          <a:bodyPr rtlCol="0" anchor="ctr"/>
+          <a:lstStyle/>
+          <a:p>
+            <a:pPr algn="ctr"/>
+          </a:p>
+        </p:txBody>
+      </p:sp>
+      <p:sp>
+        <p:nvSpPr>
+          <p:cNvPr id="34" name="Texto proyecto Negocio"/>
+          <p:cNvSpPr txBox="1"/>
+          <p:nvPr/>
+        </p:nvSpPr>
+        <p:spPr>
+          <a:xfrm>
+            <a:off x="3246120" y="1920239"/>
+            <a:ext cx="5303520" cy="548640"/>
+          </a:xfrm>
+          <a:prstGeom prst="rect">
+            <a:avLst/>
+          </a:prstGeom>
+          <a:noFill/>
+        </p:spPr>
+        <p:txBody>
+          <a:bodyPr wrap="square" lIns="0" rIns="0" tIns="0" bIns="0" anchor="ctr">
+            <a:spAutoFit/>
+          </a:bodyPr>
+          <a:lstStyle/>
+          <a:p>
+            <a:pPr algn="l"/>
+            <a:r>
+              <a:rPr sz="1400" b="1">
+                <a:solidFill>
+                  <a:schemeClr val="tx2"/>
+                </a:solidFill>
+                <a:latin typeface="Calibri"/>
+              </a:rPr>
+              <a:t>GestionContratos.Negocio</a:t>
+            </a:r>
+          </a:p>
+          <a:p>
+            <a:pPr algn="l"/>
+            <a:r>
+              <a:rPr sz="1400" b="0">
+                <a:solidFill>
+                  <a:schemeClr val="tx2"/>
+                </a:solidFill>
+                <a:latin typeface="Calibri"/>
+              </a:rPr>
+              <a:t>Servicios, reglas del negocio y analíticas</a:t>
+            </a:r>
+          </a:p>
+        </p:txBody>
+      </p:sp>
+      <p:sp>
+        <p:nvSpPr>
+          <p:cNvPr id="35" name="Capa Datos"/>
           <p:cNvSpPr/>
           <p:nvPr/>
         </p:nvSpPr>
         <p:spPr>
           <a:xfrm>
-            <a:off x="4572000" y="3035808"/>
-            <a:ext cx="411480" cy="411480"/>
-          </a:xfrm>
-          <a:prstGeom prst="ellipse">
-            <a:avLst/>
+            <a:off x="457200" y="2606039"/>
+            <a:ext cx="2468880" cy="640080"/>
+          </a:xfrm>
+          <a:prstGeom prst="roundRect">
+            <a:avLst>
+              <a:gd name="adj" fmla="val 5000"/>
+            </a:avLst>
           </a:prstGeom>
           <a:solidFill>
-            <a:srgbClr val="17673F"/>
+            <a:schemeClr val="accent1"/>
           </a:solidFill>
-          <a:ln/>
-        </p:spPr>
-        <p:txBody>
-          <a:bodyPr/>
-          <a:lstStyle/>
-          <a:p>
-            <a:endParaRPr lang="es-PE"/>
-          </a:p>
-        </p:txBody>
-      </p:sp>
-      <p:pic>
-        <p:nvPicPr>
-          <p:cNvPr id="20" name="Icono ¿Qué ganamos?" descr="Icono ¿Qué ganamos?"/>
-          <p:cNvPicPr>
-            <a:picLocks noChangeAspect="1"/>
-          </p:cNvPicPr>
-          <p:nvPr/>
-        </p:nvPicPr>
-        <p:blipFill>
-          <a:blip r:embed="rId4"/>
-          <a:stretch>
-            <a:fillRect/>
-          </a:stretch>
-        </p:blipFill>
-        <p:spPr>
-          <a:xfrm>
-            <a:off x="4674870" y="3138678"/>
-            <a:ext cx="205740" cy="205740"/>
-          </a:xfrm>
-          <a:prstGeom prst="rect">
-            <a:avLst/>
-          </a:prstGeom>
-        </p:spPr>
-      </p:pic>
-      <p:sp>
-        <p:nvSpPr>
-          <p:cNvPr id="21" name="Título ¿Qué ganamos?"/>
-          <p:cNvSpPr txBox="1"/>
-          <p:nvPr/>
-        </p:nvSpPr>
-        <p:spPr>
-          <a:xfrm>
-            <a:off x="5120640" y="3035808"/>
-            <a:ext cx="3383280" cy="411480"/>
-          </a:xfrm>
-          <a:prstGeom prst="rect">
-            <a:avLst/>
-          </a:prstGeom>
-          <a:noFill/>
-          <a:ln/>
-        </p:spPr>
-        <p:txBody>
-          <a:bodyPr wrap="square" lIns="0" tIns="0" rIns="0" bIns="0" rtlCol="0" anchor="ctr"/>
-          <a:lstStyle/>
-          <a:p>
-            <a:pPr marL="0" indent="0">
-              <a:buNone/>
-            </a:pPr>
-            <a:r>
-              <a:rPr lang="en-US" sz="1600" b="1" dirty="0">
+          <a:ln>
+            <a:noFill/>
+          </a:ln>
+        </p:spPr>
+        <p:txBody>
+          <a:bodyPr rtlCol="0" anchor="ctr"/>
+          <a:lstStyle/>
+          <a:p>
+            <a:pPr algn="ctr"/>
+          </a:p>
+        </p:txBody>
+      </p:sp>
+      <p:sp>
+        <p:nvSpPr>
+          <p:cNvPr id="36" name="Nombre capa Datos"/>
+          <p:cNvSpPr txBox="1"/>
+          <p:nvPr/>
+        </p:nvSpPr>
+        <p:spPr>
+          <a:xfrm>
+            <a:off x="594360" y="2606039"/>
+            <a:ext cx="2194560" cy="640080"/>
+          </a:xfrm>
+          <a:prstGeom prst="rect">
+            <a:avLst/>
+          </a:prstGeom>
+          <a:noFill/>
+        </p:spPr>
+        <p:txBody>
+          <a:bodyPr wrap="square" lIns="0" rIns="0" tIns="0" bIns="0" anchor="ctr">
+            <a:spAutoFit/>
+          </a:bodyPr>
+          <a:lstStyle/>
+          <a:p>
+            <a:pPr algn="l"/>
+            <a:r>
+              <a:rPr sz="1800" b="1">
+                <a:solidFill>
+                  <a:srgbClr val="FFFFFF"/>
+                </a:solidFill>
+                <a:latin typeface="Cambria"/>
+              </a:rPr>
+              <a:t>Datos</a:t>
+            </a:r>
+          </a:p>
+        </p:txBody>
+      </p:sp>
+      <p:sp>
+        <p:nvSpPr>
+          <p:cNvPr id="37" name="Proyecto Datos"/>
+          <p:cNvSpPr/>
+          <p:nvPr/>
+        </p:nvSpPr>
+        <p:spPr>
+          <a:xfrm>
+            <a:off x="3063240" y="2606039"/>
+            <a:ext cx="5623560" cy="640080"/>
+          </a:xfrm>
+          <a:prstGeom prst="roundRect">
+            <a:avLst>
+              <a:gd name="adj" fmla="val 5000"/>
+            </a:avLst>
+          </a:prstGeom>
+          <a:solidFill>
+            <a:schemeClr val="bg2"/>
+          </a:solidFill>
+          <a:ln w="12700">
+            <a:solidFill>
+              <a:srgbClr val="DCE4EA"/>
+            </a:solidFill>
+          </a:ln>
+        </p:spPr>
+        <p:txBody>
+          <a:bodyPr rtlCol="0" anchor="ctr"/>
+          <a:lstStyle/>
+          <a:p>
+            <a:pPr algn="ctr"/>
+          </a:p>
+        </p:txBody>
+      </p:sp>
+      <p:sp>
+        <p:nvSpPr>
+          <p:cNvPr id="38" name="Texto proyecto Datos"/>
+          <p:cNvSpPr txBox="1"/>
+          <p:nvPr/>
+        </p:nvSpPr>
+        <p:spPr>
+          <a:xfrm>
+            <a:off x="3246120" y="2651759"/>
+            <a:ext cx="5303520" cy="548640"/>
+          </a:xfrm>
+          <a:prstGeom prst="rect">
+            <a:avLst/>
+          </a:prstGeom>
+          <a:noFill/>
+        </p:spPr>
+        <p:txBody>
+          <a:bodyPr wrap="square" lIns="0" rIns="0" tIns="0" bIns="0" anchor="ctr">
+            <a:spAutoFit/>
+          </a:bodyPr>
+          <a:lstStyle/>
+          <a:p>
+            <a:pPr algn="l"/>
+            <a:r>
+              <a:rPr sz="1400" b="1">
                 <a:solidFill>
                   <a:schemeClr val="tx2"/>
                 </a:solidFill>
-                <a:latin typeface="Calibri" pitchFamily="34" charset="0"/>
-                <a:ea typeface="Calibri" pitchFamily="34" charset="-122"/>
-                <a:cs typeface="Calibri" pitchFamily="34" charset="-120"/>
-              </a:rPr>
-              <a:t>¿Qué ganamos?</a:t>
-            </a:r>
-            <a:endParaRPr lang="en-US" sz="1600" dirty="0"/>
-          </a:p>
-        </p:txBody>
-      </p:sp>
-      <p:sp>
-        <p:nvSpPr>
-          <p:cNvPr id="22" name="Lista ¿Qué ganamos?"/>
-          <p:cNvSpPr txBox="1"/>
-          <p:nvPr/>
-        </p:nvSpPr>
-        <p:spPr>
-          <a:xfrm>
-            <a:off x="4572000" y="3520440"/>
-            <a:ext cx="3931920" cy="960120"/>
-          </a:xfrm>
-          <a:prstGeom prst="rect">
-            <a:avLst/>
-          </a:prstGeom>
-          <a:noFill/>
-          <a:ln/>
-        </p:spPr>
-        <p:txBody>
-          <a:bodyPr wrap="square" lIns="0" tIns="0" rIns="0" bIns="0" rtlCol="0" anchor="t"/>
-          <a:lstStyle/>
-          <a:p>
-            <a:pPr marL="342900" indent="-342900">
-              <a:spcAft>
-                <a:spcPts val="200"/>
-              </a:spcAft>
-              <a:buSzPct val="100000"/>
-              <a:buChar char="•"/>
-            </a:pPr>
-            <a:r>
-              <a:rPr lang="en-US" sz="1400" dirty="0">
-                <a:solidFill>
-                  <a:schemeClr val="tx1"/>
-                </a:solidFill>
-                <a:latin typeface="Calibri" pitchFamily="34" charset="0"/>
-                <a:ea typeface="Calibri" pitchFamily="34" charset="-122"/>
-                <a:cs typeface="Calibri" pitchFamily="34" charset="-120"/>
-              </a:rPr>
-              <a:t>Cada capa se prueba por separado</a:t>
-            </a:r>
-            <a:endParaRPr lang="en-US" sz="1400" dirty="0"/>
-          </a:p>
-          <a:p>
-            <a:pPr marL="342900" indent="-342900">
-              <a:spcAft>
-                <a:spcPts val="200"/>
-              </a:spcAft>
-              <a:buSzPct val="100000"/>
-              <a:buChar char="•"/>
-            </a:pPr>
-            <a:r>
-              <a:rPr lang="en-US" sz="1400" dirty="0">
-                <a:solidFill>
-                  <a:schemeClr val="tx1"/>
-                </a:solidFill>
-                <a:latin typeface="Calibri" pitchFamily="34" charset="0"/>
-                <a:ea typeface="Calibri" pitchFamily="34" charset="-122"/>
-                <a:cs typeface="Calibri" pitchFamily="34" charset="-120"/>
-              </a:rPr>
-              <a:t>Un cambio no rompe el resto</a:t>
-            </a:r>
-            <a:endParaRPr lang="en-US" sz="1400" dirty="0"/>
-          </a:p>
-          <a:p>
-            <a:pPr marL="342900" indent="-342900">
-              <a:spcAft>
-                <a:spcPts val="200"/>
-              </a:spcAft>
-              <a:buSzPct val="100000"/>
-              <a:buChar char="•"/>
-            </a:pPr>
-            <a:r>
-              <a:rPr lang="en-US" sz="1400" dirty="0">
-                <a:solidFill>
-                  <a:schemeClr val="tx1"/>
-                </a:solidFill>
-                <a:latin typeface="Calibri" pitchFamily="34" charset="0"/>
-                <a:ea typeface="Calibri" pitchFamily="34" charset="-122"/>
-                <a:cs typeface="Calibri" pitchFamily="34" charset="-120"/>
-              </a:rPr>
-              <a:t>Listo para crecer: la facturación electrónica ya tiene su lugar</a:t>
-            </a:r>
-            <a:endParaRPr lang="en-US" sz="1400" dirty="0"/>
-          </a:p>
-        </p:txBody>
-      </p:sp>
-      <p:sp>
-        <p:nvSpPr>
-          <p:cNvPr id="25" name="Slide Number Placeholder 0"/>
-          <p:cNvSpPr>
-            <a:spLocks noGrp="1"/>
-          </p:cNvSpPr>
-          <p:nvPr>
-            <p:ph type="sldNum" sz="quarter" idx="4294967295"/>
-          </p:nvPr>
-        </p:nvSpPr>
-        <p:spPr>
-          <a:xfrm>
-            <a:off x="8229600" y="4754880"/>
-            <a:ext cx="457200" cy="228600"/>
-          </a:xfrm>
-          <a:prstGeom prst="rect">
-            <a:avLst/>
-          </a:prstGeom>
-          <a:extLst>
-            <a:ext uri="{C572A759-6A51-4108-AA02-DFA0A04FC94B}">
-              <ma14:wrappingTextBoxFlag xmlns:ma14="http://schemas.microsoft.com/office/mac/drawingml/2011/main" xmlns="" val="0"/>
-            </a:ext>
-          </a:extLst>
-        </p:spPr>
-        <p:txBody>
-          <a:bodyPr/>
-          <a:lstStyle>
-            <a:lvl1pPr>
-              <a:defRPr sz="1000">
+                <a:latin typeface="Calibri"/>
+              </a:rPr>
+              <a:t>GestionContratos.Datos</a:t>
+            </a:r>
+          </a:p>
+          <a:p>
+            <a:pPr algn="l"/>
+            <a:r>
+              <a:rPr sz="1400" b="0">
                 <a:solidFill>
                   <a:schemeClr val="tx2"/>
                 </a:solidFill>
-              </a:defRPr>
-            </a:lvl1pPr>
-          </a:lstStyle>
-          <a:p>
-            <a:pPr algn="r"/>
-            <a:fld id="{F7021451-1387-4CA6-816F-3879F97B5CBC}" type="slidenum">
-              <a:rPr lang="en-US" b="0"/>
-              <a:t>5</a:t>
-            </a:fld>
-            <a:endParaRPr lang="en-US"/>
+                <a:latin typeface="Calibri"/>
+              </a:rPr>
+              <a:t>DbContext de EF Core, repositorios y Unit of Work</a:t>
+            </a:r>
+          </a:p>
+        </p:txBody>
+      </p:sp>
+      <p:sp>
+        <p:nvSpPr>
+          <p:cNvPr id="39" name="Capa Entidades"/>
+          <p:cNvSpPr/>
+          <p:nvPr/>
+        </p:nvSpPr>
+        <p:spPr>
+          <a:xfrm>
+            <a:off x="457200" y="3337559"/>
+            <a:ext cx="2468880" cy="640080"/>
+          </a:xfrm>
+          <a:prstGeom prst="roundRect">
+            <a:avLst>
+              <a:gd name="adj" fmla="val 5000"/>
+            </a:avLst>
+          </a:prstGeom>
+          <a:solidFill>
+            <a:schemeClr val="accent1"/>
+          </a:solidFill>
+          <a:ln>
+            <a:noFill/>
+          </a:ln>
+        </p:spPr>
+        <p:txBody>
+          <a:bodyPr rtlCol="0" anchor="ctr"/>
+          <a:lstStyle/>
+          <a:p>
+            <a:pPr algn="ctr"/>
+          </a:p>
+        </p:txBody>
+      </p:sp>
+      <p:sp>
+        <p:nvSpPr>
+          <p:cNvPr id="40" name="Nombre capa Entidades"/>
+          <p:cNvSpPr txBox="1"/>
+          <p:nvPr/>
+        </p:nvSpPr>
+        <p:spPr>
+          <a:xfrm>
+            <a:off x="594360" y="3337559"/>
+            <a:ext cx="2194560" cy="640080"/>
+          </a:xfrm>
+          <a:prstGeom prst="rect">
+            <a:avLst/>
+          </a:prstGeom>
+          <a:noFill/>
+        </p:spPr>
+        <p:txBody>
+          <a:bodyPr wrap="square" lIns="0" rIns="0" tIns="0" bIns="0" anchor="ctr">
+            <a:spAutoFit/>
+          </a:bodyPr>
+          <a:lstStyle/>
+          <a:p>
+            <a:pPr algn="l"/>
+            <a:r>
+              <a:rPr sz="1800" b="1">
+                <a:solidFill>
+                  <a:srgbClr val="FFFFFF"/>
+                </a:solidFill>
+                <a:latin typeface="Cambria"/>
+              </a:rPr>
+              <a:t>Entidades</a:t>
+            </a:r>
+          </a:p>
+        </p:txBody>
+      </p:sp>
+      <p:sp>
+        <p:nvSpPr>
+          <p:cNvPr id="41" name="Proyecto Entidades"/>
+          <p:cNvSpPr/>
+          <p:nvPr/>
+        </p:nvSpPr>
+        <p:spPr>
+          <a:xfrm>
+            <a:off x="3063240" y="3337559"/>
+            <a:ext cx="5623560" cy="640080"/>
+          </a:xfrm>
+          <a:prstGeom prst="roundRect">
+            <a:avLst>
+              <a:gd name="adj" fmla="val 5000"/>
+            </a:avLst>
+          </a:prstGeom>
+          <a:solidFill>
+            <a:schemeClr val="bg2"/>
+          </a:solidFill>
+          <a:ln w="12700">
+            <a:solidFill>
+              <a:srgbClr val="DCE4EA"/>
+            </a:solidFill>
+          </a:ln>
+        </p:spPr>
+        <p:txBody>
+          <a:bodyPr rtlCol="0" anchor="ctr"/>
+          <a:lstStyle/>
+          <a:p>
+            <a:pPr algn="ctr"/>
+          </a:p>
+        </p:txBody>
+      </p:sp>
+      <p:sp>
+        <p:nvSpPr>
+          <p:cNvPr id="42" name="Texto proyecto Entidades"/>
+          <p:cNvSpPr txBox="1"/>
+          <p:nvPr/>
+        </p:nvSpPr>
+        <p:spPr>
+          <a:xfrm>
+            <a:off x="3246120" y="3383279"/>
+            <a:ext cx="5303520" cy="548640"/>
+          </a:xfrm>
+          <a:prstGeom prst="rect">
+            <a:avLst/>
+          </a:prstGeom>
+          <a:noFill/>
+        </p:spPr>
+        <p:txBody>
+          <a:bodyPr wrap="square" lIns="0" rIns="0" tIns="0" bIns="0" anchor="ctr">
+            <a:spAutoFit/>
+          </a:bodyPr>
+          <a:lstStyle/>
+          <a:p>
+            <a:pPr algn="l"/>
+            <a:r>
+              <a:rPr sz="1400" b="1">
+                <a:solidFill>
+                  <a:schemeClr val="tx2"/>
+                </a:solidFill>
+                <a:latin typeface="Calibri"/>
+              </a:rPr>
+              <a:t>GestionContratos.Entidades</a:t>
+            </a:r>
+          </a:p>
+          <a:p>
+            <a:pPr algn="l"/>
+            <a:r>
+              <a:rPr sz="1400" b="0">
+                <a:solidFill>
+                  <a:schemeClr val="tx2"/>
+                </a:solidFill>
+                <a:latin typeface="Calibri"/>
+              </a:rPr>
+              <a:t>Clases de las tablas; no depende de ninguna otra</a:t>
+            </a:r>
+          </a:p>
+        </p:txBody>
+      </p:sp>
+      <p:sp>
+        <p:nvSpPr>
+          <p:cNvPr id="43" name="Mensaje arquitectura"/>
+          <p:cNvSpPr/>
+          <p:nvPr/>
+        </p:nvSpPr>
+        <p:spPr>
+          <a:xfrm>
+            <a:off x="457200" y="4069080"/>
+            <a:ext cx="8229600" cy="640080"/>
+          </a:xfrm>
+          <a:prstGeom prst="roundRect">
+            <a:avLst>
+              <a:gd name="adj" fmla="val 15000"/>
+            </a:avLst>
+          </a:prstGeom>
+          <a:solidFill>
+            <a:schemeClr val="accent6"/>
+          </a:solidFill>
+          <a:ln>
+            <a:noFill/>
+          </a:ln>
+        </p:spPr>
+        <p:txBody>
+          <a:bodyPr rtlCol="0" anchor="ctr"/>
+          <a:lstStyle/>
+          <a:p>
+            <a:pPr algn="ctr"/>
+          </a:p>
+        </p:txBody>
+      </p:sp>
+      <p:sp>
+        <p:nvSpPr>
+          <p:cNvPr id="44" name="Texto arquitectura"/>
+          <p:cNvSpPr txBox="1"/>
+          <p:nvPr/>
+        </p:nvSpPr>
+        <p:spPr>
+          <a:xfrm>
+            <a:off x="731520" y="4069080"/>
+            <a:ext cx="7680960" cy="640080"/>
+          </a:xfrm>
+          <a:prstGeom prst="rect">
+            <a:avLst/>
+          </a:prstGeom>
+          <a:noFill/>
+        </p:spPr>
+        <p:txBody>
+          <a:bodyPr wrap="square" lIns="0" rIns="0" tIns="0" bIns="0" anchor="ctr">
+            <a:spAutoFit/>
+          </a:bodyPr>
+          <a:lstStyle/>
+          <a:p>
+            <a:pPr algn="l"/>
+            <a:r>
+              <a:rPr sz="1400" b="1">
+                <a:solidFill>
+                  <a:schemeClr val="tx2"/>
+                </a:solidFill>
+                <a:latin typeface="Calibri"/>
+              </a:rPr>
+              <a:t>Apoyo: DTOs · Comun · Integraciones · Pruebas</a:t>
+            </a:r>
+          </a:p>
+          <a:p>
+            <a:pPr algn="l"/>
+            <a:r>
+              <a:rPr sz="1400" b="1">
+                <a:solidFill>
+                  <a:schemeClr val="tx2"/>
+                </a:solidFill>
+                <a:latin typeface="Calibri"/>
+              </a:rPr>
+              <a:t>.NET 10 · Entity Framework Core · SQL Server · Angular 21 consume la API</a:t>
+            </a:r>
           </a:p>
         </p:txBody>
       </p:sp>
@@ -8354,7 +10617,7 @@
                 <a:ea typeface="Cambria" pitchFamily="34" charset="-122"/>
                 <a:cs typeface="Cambria" pitchFamily="34" charset="-120"/>
               </a:rPr>
-              <a:t>Decisiones técnicas clave</a:t>
+              <a:t>Decisiones técnicas clave (ADR)</a:t>
             </a:r>
             <a:endParaRPr lang="en-US" sz="3000" dirty="0"/>
           </a:p>
@@ -8470,7 +10733,7 @@
               <a:buNone/>
             </a:pPr>
             <a:r>
-              <a:rPr lang="en-US" sz="1800" b="1" dirty="0">
+              <a:rPr lang="en-US" sz="1600" b="1" dirty="0">
                 <a:solidFill>
                   <a:schemeClr val="tx2"/>
                 </a:solidFill>
@@ -8478,7 +10741,7 @@
                 <a:ea typeface="Calibri" pitchFamily="34" charset="-122"/>
                 <a:cs typeface="Calibri" pitchFamily="34" charset="-120"/>
               </a:rPr>
-              <a:t>Base de datos primero</a:t>
+              <a:t>ADR-1 · Base de datos primero</a:t>
             </a:r>
             <a:endParaRPr lang="en-US" sz="1800" dirty="0"/>
           </a:p>
@@ -8517,7 +10780,7 @@
                 <a:ea typeface="Calibri" pitchFamily="34" charset="-122"/>
                 <a:cs typeface="Calibri" pitchFamily="34" charset="-120"/>
               </a:rPr>
-              <a:t>Es la fuente de verdad: el código se generó a partir de ella.</a:t>
+              <a:t>La BD es la fuente de verdad; las entidades se generan con EF Core scaffold.</a:t>
             </a:r>
             <a:endParaRPr lang="en-US" sz="1400" dirty="0"/>
           </a:p>
@@ -8633,7 +10896,7 @@
               <a:buNone/>
             </a:pPr>
             <a:r>
-              <a:rPr lang="en-US" sz="1800" b="1" dirty="0">
+              <a:rPr lang="en-US" sz="1600" b="1" dirty="0">
                 <a:solidFill>
                   <a:schemeClr val="tx2"/>
                 </a:solidFill>
@@ -8641,7 +10904,7 @@
                 <a:ea typeface="Calibri" pitchFamily="34" charset="-122"/>
                 <a:cs typeface="Calibri" pitchFamily="34" charset="-120"/>
               </a:rPr>
-              <a:t>Claves protegidas</a:t>
+              <a:t>ADR-2 · Claves protegidas</a:t>
             </a:r>
             <a:endParaRPr lang="en-US" sz="1800" dirty="0"/>
           </a:p>
@@ -8680,7 +10943,7 @@
                 <a:ea typeface="Calibri" pitchFamily="34" charset="-122"/>
                 <a:cs typeface="Calibri" pitchFamily="34" charset="-120"/>
               </a:rPr>
-              <a:t>Nunca se suben al repositorio; van en variables seguras.</a:t>
+              <a:t>Cadena de conexión y clave JWT en user-secrets, nunca en el repositorio.</a:t>
             </a:r>
             <a:endParaRPr lang="en-US" sz="1400" dirty="0"/>
           </a:p>
@@ -8796,7 +11059,7 @@
               <a:buNone/>
             </a:pPr>
             <a:r>
-              <a:rPr lang="en-US" sz="1800" b="1" dirty="0">
+              <a:rPr lang="en-US" sz="1600" b="1" dirty="0">
                 <a:solidFill>
                   <a:schemeClr val="tx2"/>
                 </a:solidFill>
@@ -8804,7 +11067,7 @@
                 <a:ea typeface="Calibri" pitchFamily="34" charset="-122"/>
                 <a:cs typeface="Calibri" pitchFamily="34" charset="-120"/>
               </a:rPr>
-              <a:t>Nada se borra de verdad</a:t>
+              <a:t>ADR-3 · Baja lógica</a:t>
             </a:r>
             <a:endParaRPr lang="en-US" sz="1800" dirty="0"/>
           </a:p>
@@ -8843,7 +11106,7 @@
                 <a:ea typeface="Calibri" pitchFamily="34" charset="-122"/>
                 <a:cs typeface="Calibri" pitchFamily="34" charset="-120"/>
               </a:rPr>
-              <a:t>Los registros se desactivan, así queda el historial.</a:t>
+              <a:t>Filtro global de EF Core: los registros se desactivan y queda el historial.</a:t>
             </a:r>
             <a:endParaRPr lang="en-US" sz="1400" dirty="0"/>
           </a:p>
@@ -8959,7 +11222,7 @@
               <a:buNone/>
             </a:pPr>
             <a:r>
-              <a:rPr lang="en-US" sz="1800" b="1" dirty="0">
+              <a:rPr lang="en-US" sz="1600" b="1" dirty="0">
                 <a:solidFill>
                   <a:schemeClr val="tx2"/>
                 </a:solidFill>
@@ -8967,7 +11230,7 @@
                 <a:ea typeface="Calibri" pitchFamily="34" charset="-122"/>
                 <a:cs typeface="Calibri" pitchFamily="34" charset="-120"/>
               </a:rPr>
-              <a:t>Un solo sitio</a:t>
+              <a:t>ADR-4 · Despliegue en IIS</a:t>
             </a:r>
             <a:endParaRPr lang="en-US" sz="1800" dirty="0"/>
           </a:p>
@@ -9006,7 +11269,7 @@
                 <a:ea typeface="Calibri" pitchFamily="34" charset="-122"/>
                 <a:cs typeface="Calibri" pitchFamily="34" charset="-120"/>
               </a:rPr>
-              <a:t>La web y el sistema se instalan juntos en IIS.</a:t>
+              <a:t>La API sirve la web compilada: se instala un solo sitio.</a:t>
             </a:r>
             <a:endParaRPr lang="en-US" sz="1400" dirty="0"/>
           </a:p>
@@ -9051,9 +11314,44 @@
             <a:pPr algn="r"/>
             <a:fld id="{F7021451-1387-4CA6-816F-3879F97B5CBC}" type="slidenum">
               <a:rPr lang="en-US" b="0"/>
-              <a:t>6</a:t>
+              <a:t>8</a:t>
             </a:fld>
             <a:endParaRPr lang="en-US"/>
+          </a:p>
+        </p:txBody>
+      </p:sp>
+      <p:sp>
+        <p:nvSpPr>
+          <p:cNvPr id="26" name="Etiqueta de sección"/>
+          <p:cNvSpPr txBox="1"/>
+          <p:nvPr/>
+        </p:nvSpPr>
+        <p:spPr>
+          <a:xfrm>
+            <a:off x="457200" y="91440"/>
+            <a:ext cx="7863840" cy="228600"/>
+          </a:xfrm>
+          <a:prstGeom prst="rect">
+            <a:avLst/>
+          </a:prstGeom>
+          <a:noFill/>
+        </p:spPr>
+        <p:txBody>
+          <a:bodyPr wrap="square" lIns="0" rIns="0" tIns="0" bIns="0" anchor="ctr">
+            <a:spAutoFit/>
+          </a:bodyPr>
+          <a:lstStyle/>
+          <a:p>
+            <a:pPr algn="l"/>
+            <a:r>
+              <a:rPr sz="1100" b="1">
+                <a:solidFill>
+                  <a:schemeClr val="accent1"/>
+                </a:solidFill>
+                <a:latin typeface="Calibri"/>
+              </a:rPr>
+              <a:t>3 · ARQUITECTURA Y DECISIONES TÉCNICAS</a:t>
+            </a:r>
           </a:p>
         </p:txBody>
       </p:sp>
@@ -9495,7 +11793,7 @@
                 <a:ea typeface="Calibri" pitchFamily="34" charset="-122"/>
                 <a:cs typeface="Calibri" pitchFamily="34" charset="-120"/>
               </a:rPr>
-              <a:t>Propuso la arquitectura</a:t>
+              <a:t>Implementó las N capas que indiqué</a:t>
             </a:r>
             <a:endParaRPr lang="en-US" sz="1400" dirty="0"/>
           </a:p>
@@ -9859,9 +12157,44 @@
             <a:pPr algn="r"/>
             <a:fld id="{F7021451-1387-4CA6-816F-3879F97B5CBC}" type="slidenum">
               <a:rPr lang="en-US" b="0"/>
-              <a:t>7</a:t>
+              <a:t>9</a:t>
             </a:fld>
             <a:endParaRPr lang="en-US"/>
+          </a:p>
+        </p:txBody>
+      </p:sp>
+      <p:sp>
+        <p:nvSpPr>
+          <p:cNvPr id="26" name="Etiqueta de sección"/>
+          <p:cNvSpPr txBox="1"/>
+          <p:nvPr/>
+        </p:nvSpPr>
+        <p:spPr>
+          <a:xfrm>
+            <a:off x="457200" y="91440"/>
+            <a:ext cx="7863840" cy="228600"/>
+          </a:xfrm>
+          <a:prstGeom prst="rect">
+            <a:avLst/>
+          </a:prstGeom>
+          <a:noFill/>
+        </p:spPr>
+        <p:txBody>
+          <a:bodyPr wrap="square" lIns="0" rIns="0" tIns="0" bIns="0" anchor="ctr">
+            <a:spAutoFit/>
+          </a:bodyPr>
+          <a:lstStyle/>
+          <a:p>
+            <a:pPr algn="l"/>
+            <a:r>
+              <a:rPr sz="1100" b="1">
+                <a:solidFill>
+                  <a:schemeClr val="accent1"/>
+                </a:solidFill>
+                <a:latin typeface="Calibri"/>
+              </a:rPr>
+              <a:t>4 · INTELIGENCIA ARTIFICIAL Y EVIDENCIA DE REVISIÓN</a:t>
+            </a:r>
           </a:p>
         </p:txBody>
       </p:sp>
@@ -9927,7 +12260,7 @@
                 <a:ea typeface="Cambria" pitchFamily="34" charset="-122"/>
                 <a:cs typeface="Cambria" pitchFamily="34" charset="-120"/>
               </a:rPr>
-              <a:t>La IA también se equivoca</a:t>
+              <a:t>La IA también se equivoca: revisión crítica</a:t>
             </a:r>
             <a:endParaRPr lang="en-US" sz="3000" dirty="0"/>
           </a:p>
@@ -10574,9 +12907,44 @@
             <a:pPr algn="r"/>
             <a:fld id="{F7021451-1387-4CA6-816F-3879F97B5CBC}" type="slidenum">
               <a:rPr lang="en-US" b="0"/>
-              <a:t>8</a:t>
+              <a:t>11</a:t>
             </a:fld>
             <a:endParaRPr lang="en-US"/>
+          </a:p>
+        </p:txBody>
+      </p:sp>
+      <p:sp>
+        <p:nvSpPr>
+          <p:cNvPr id="26" name="Etiqueta de sección"/>
+          <p:cNvSpPr txBox="1"/>
+          <p:nvPr/>
+        </p:nvSpPr>
+        <p:spPr>
+          <a:xfrm>
+            <a:off x="457200" y="91440"/>
+            <a:ext cx="7863840" cy="228600"/>
+          </a:xfrm>
+          <a:prstGeom prst="rect">
+            <a:avLst/>
+          </a:prstGeom>
+          <a:noFill/>
+        </p:spPr>
+        <p:txBody>
+          <a:bodyPr wrap="square" lIns="0" rIns="0" tIns="0" bIns="0" anchor="ctr">
+            <a:spAutoFit/>
+          </a:bodyPr>
+          <a:lstStyle/>
+          <a:p>
+            <a:pPr algn="l"/>
+            <a:r>
+              <a:rPr sz="1100" b="1">
+                <a:solidFill>
+                  <a:schemeClr val="accent1"/>
+                </a:solidFill>
+                <a:latin typeface="Calibri"/>
+              </a:rPr>
+              <a:t>4 · INTELIGENCIA ARTIFICIAL Y EVIDENCIA DE REVISIÓN</a:t>
+            </a:r>
           </a:p>
         </p:txBody>
       </p:sp>
@@ -10642,7 +13010,7 @@
                 <a:ea typeface="Cambria" pitchFamily="34" charset="-122"/>
                 <a:cs typeface="Cambria" pitchFamily="34" charset="-120"/>
               </a:rPr>
-              <a:t>Comprobamos que funciona</a:t>
+              <a:t>Validación técnica del sistema</a:t>
             </a:r>
             <a:endParaRPr lang="en-US" sz="3000" dirty="0"/>
           </a:p>
@@ -11434,9 +13802,44 @@
             <a:pPr algn="r"/>
             <a:fld id="{F7021451-1387-4CA6-816F-3879F97B5CBC}" type="slidenum">
               <a:rPr lang="en-US" b="0"/>
-              <a:t>9</a:t>
+              <a:t>6</a:t>
             </a:fld>
             <a:endParaRPr lang="en-US"/>
+          </a:p>
+        </p:txBody>
+      </p:sp>
+      <p:sp>
+        <p:nvSpPr>
+          <p:cNvPr id="26" name="Etiqueta de sección"/>
+          <p:cNvSpPr txBox="1"/>
+          <p:nvPr/>
+        </p:nvSpPr>
+        <p:spPr>
+          <a:xfrm>
+            <a:off x="457200" y="91440"/>
+            <a:ext cx="7863840" cy="228600"/>
+          </a:xfrm>
+          <a:prstGeom prst="rect">
+            <a:avLst/>
+          </a:prstGeom>
+          <a:noFill/>
+        </p:spPr>
+        <p:txBody>
+          <a:bodyPr wrap="square" lIns="0" rIns="0" tIns="0" bIns="0" anchor="ctr">
+            <a:spAutoFit/>
+          </a:bodyPr>
+          <a:lstStyle/>
+          <a:p>
+            <a:pPr algn="l"/>
+            <a:r>
+              <a:rPr sz="1100" b="1">
+                <a:solidFill>
+                  <a:schemeClr val="accent1"/>
+                </a:solidFill>
+                <a:latin typeface="Calibri"/>
+              </a:rPr>
+              <a:t>2 · ESPECIFICACIONES Y TRAZABILIDAD</a:t>
+            </a:r>
           </a:p>
         </p:txBody>
       </p:sp>

</xml_diff>